<commit_message>
update Think & Speak Slides
</commit_message>
<xml_diff>
--- a/Think and Speak/olateju_ECE563_thnk&speak.pptx
+++ b/Think and Speak/olateju_ECE563_thnk&speak.pptx
@@ -5,23 +5,23 @@
     <p:sldMasterId id="2147483648" r:id="rId1"/>
   </p:sldMasterIdLst>
   <p:notesMasterIdLst>
-    <p:notesMasterId r:id="rId11"/>
+    <p:notesMasterId r:id="rId10"/>
   </p:notesMasterIdLst>
   <p:handoutMasterIdLst>
-    <p:handoutMasterId r:id="rId12"/>
+    <p:handoutMasterId r:id="rId11"/>
   </p:handoutMasterIdLst>
   <p:sldIdLst>
-    <p:sldId id="256" r:id="rId3"/>
-    <p:sldId id="257" r:id="rId4"/>
-    <p:sldId id="258" r:id="rId5"/>
-    <p:sldId id="259" r:id="rId6"/>
-    <p:sldId id="260" r:id="rId7"/>
-    <p:sldId id="261" r:id="rId8"/>
-    <p:sldId id="263" r:id="rId9"/>
-    <p:sldId id="262" r:id="rId10"/>
+    <p:sldId id="256" r:id="rId2"/>
+    <p:sldId id="257" r:id="rId3"/>
+    <p:sldId id="258" r:id="rId4"/>
+    <p:sldId id="259" r:id="rId5"/>
+    <p:sldId id="260" r:id="rId6"/>
+    <p:sldId id="261" r:id="rId7"/>
+    <p:sldId id="263" r:id="rId8"/>
+    <p:sldId id="262" r:id="rId9"/>
   </p:sldIdLst>
   <p:sldSz cx="12192000" cy="6858000"/>
-  <p:notesSz cx="7103745" cy="10234295"/>
+  <p:notesSz cx="7104063" cy="10234613"/>
   <p:defaultTextStyle>
     <a:defPPr>
       <a:defRPr lang="zh-CN"/>
@@ -117,6 +117,22 @@
       </a:defRPr>
     </a:lvl9pPr>
   </p:defaultTextStyle>
+  <p:extLst>
+    <p:ext uri="{EFAFB233-063F-42B5-8137-9DF3F51BA10A}">
+      <p15:sldGuideLst xmlns:p15="http://schemas.microsoft.com/office/powerpoint/2012/main">
+        <p15:guide id="1" orient="horz" pos="2123">
+          <p15:clr>
+            <a:srgbClr val="A4A3A4"/>
+          </p15:clr>
+        </p15:guide>
+        <p15:guide id="2" pos="3852">
+          <p15:clr>
+            <a:srgbClr val="A4A3A4"/>
+          </p15:clr>
+        </p15:guide>
+      </p15:sldGuideLst>
+    </p:ext>
+  </p:extLst>
 </p:presentation>
 </file>
 
@@ -202,6 +218,7 @@
           <a:p>
             <a:fld id="{0F9B84EA-7D68-4D60-9CB1-D50884785D1C}" type="datetimeFigureOut">
               <a:rPr lang="zh-CN" altLang="en-US" smtClean="0"/>
+              <a:t>2026/10/22</a:t>
             </a:fld>
             <a:endParaRPr lang="zh-CN" altLang="en-US"/>
           </a:p>
@@ -267,12 +284,18 @@
           <a:p>
             <a:fld id="{8D4E0FC9-F1F8-4FAE-9988-3BA365CFD46F}" type="slidenum">
               <a:rPr lang="zh-CN" altLang="en-US" smtClean="0"/>
+              <a:t>‹#›</a:t>
             </a:fld>
             <a:endParaRPr lang="zh-CN" altLang="en-US"/>
           </a:p>
         </p:txBody>
       </p:sp>
     </p:spTree>
+    <p:extLst>
+      <p:ext uri="{BB962C8B-B14F-4D97-AF65-F5344CB8AC3E}">
+        <p14:creationId xmlns:p14="http://schemas.microsoft.com/office/powerpoint/2010/main" val="1"/>
+      </p:ext>
+    </p:extLst>
   </p:cSld>
   <p:clrMap bg1="lt1" tx1="dk1" bg2="lt2" tx2="dk2" accent1="accent1" accent2="accent2" accent3="accent3" accent4="accent4" accent5="accent5" accent6="accent6" hlink="hlink" folHlink="folHlink"/>
 </p:handoutMaster>
@@ -360,6 +383,7 @@
           <a:p>
             <a:fld id="{D6C8D182-E4C8-4120-9249-FC9774456FFA}" type="datetimeFigureOut">
               <a:rPr lang="zh-CN" altLang="en-US" smtClean="0"/>
+              <a:t>2026/10/22</a:t>
             </a:fld>
             <a:endParaRPr lang="zh-CN" altLang="en-US"/>
           </a:p>
@@ -426,7 +450,6 @@
               <a:rPr lang="zh-CN" altLang="en-US"/>
               <a:t>编辑母版文本样式</a:t>
             </a:r>
-            <a:endParaRPr lang="zh-CN" altLang="en-US"/>
           </a:p>
           <a:p>
             <a:pPr lvl="1"/>
@@ -434,7 +457,6 @@
               <a:rPr lang="zh-CN" altLang="en-US"/>
               <a:t>第二级</a:t>
             </a:r>
-            <a:endParaRPr lang="zh-CN" altLang="en-US"/>
           </a:p>
           <a:p>
             <a:pPr lvl="2"/>
@@ -442,7 +464,6 @@
               <a:rPr lang="zh-CN" altLang="en-US"/>
               <a:t>第三级</a:t>
             </a:r>
-            <a:endParaRPr lang="zh-CN" altLang="en-US"/>
           </a:p>
           <a:p>
             <a:pPr lvl="3"/>
@@ -450,7 +471,6 @@
               <a:rPr lang="zh-CN" altLang="en-US"/>
               <a:t>第四级</a:t>
             </a:r>
-            <a:endParaRPr lang="zh-CN" altLang="en-US"/>
           </a:p>
           <a:p>
             <a:pPr lvl="4"/>
@@ -458,7 +478,6 @@
               <a:rPr lang="zh-CN" altLang="en-US"/>
               <a:t>第五级</a:t>
             </a:r>
-            <a:endParaRPr lang="zh-CN" altLang="en-US"/>
           </a:p>
         </p:txBody>
       </p:sp>
@@ -522,6 +541,7 @@
           <a:p>
             <a:fld id="{85D0DACE-38E0-42D2-9336-2B707D34BC6D}" type="slidenum">
               <a:rPr lang="zh-CN" altLang="en-US" smtClean="0"/>
+              <a:t>‹#›</a:t>
             </a:fld>
             <a:endParaRPr lang="zh-CN" altLang="en-US"/>
           </a:p>
@@ -685,9 +705,6 @@
               </a:rPr>
               <a:t>Click to edit Master title style</a:t>
             </a:r>
-            <a:endParaRPr lang="zh-CN" altLang="en-US" dirty="0">
-              <a:sym typeface="+mn-ea"/>
-            </a:endParaRPr>
           </a:p>
         </p:txBody>
       </p:sp>
@@ -708,6 +725,7 @@
           <a:p>
             <a:fld id="{760FBDFE-C587-4B4C-A407-44438C67B59E}" type="datetimeFigureOut">
               <a:rPr lang="zh-CN" altLang="en-US" smtClean="0"/>
+              <a:t>2026/10/22</a:t>
             </a:fld>
             <a:endParaRPr lang="zh-CN" altLang="en-US"/>
           </a:p>
@@ -749,6 +767,7 @@
           <a:p>
             <a:fld id="{49AE70B2-8BF9-45C0-BB95-33D1B9D3A854}" type="slidenum">
               <a:rPr lang="zh-CN" altLang="en-US" smtClean="0"/>
+              <a:t>‹#›</a:t>
             </a:fld>
             <a:endParaRPr lang="zh-CN" altLang="en-US"/>
           </a:p>
@@ -827,7 +846,6 @@
               <a:rPr lang="zh-CN" altLang="en-US" dirty="0"/>
               <a:t>Click to edit Master subtitle style</a:t>
             </a:r>
-            <a:endParaRPr lang="zh-CN" altLang="en-US" dirty="0"/>
           </a:p>
         </p:txBody>
       </p:sp>
@@ -873,6 +891,7 @@
           <a:p>
             <a:fld id="{760FBDFE-C587-4B4C-A407-44438C67B59E}" type="datetimeFigureOut">
               <a:rPr lang="zh-CN" altLang="en-US" smtClean="0"/>
+              <a:t>2026/10/22</a:t>
             </a:fld>
             <a:endParaRPr lang="zh-CN" altLang="en-US"/>
           </a:p>
@@ -914,6 +933,7 @@
           <a:p>
             <a:fld id="{49AE70B2-8BF9-45C0-BB95-33D1B9D3A854}" type="slidenum">
               <a:rPr lang="zh-CN" altLang="en-US" smtClean="0"/>
+              <a:t>‹#›</a:t>
             </a:fld>
             <a:endParaRPr lang="zh-CN" altLang="en-US"/>
           </a:p>
@@ -946,9 +966,6 @@
               </a:rPr>
               <a:t>Click to edit Master text styles</a:t>
             </a:r>
-            <a:endParaRPr lang="zh-CN" altLang="en-US" dirty="0">
-              <a:sym typeface="+mn-ea"/>
-            </a:endParaRPr>
           </a:p>
           <a:p>
             <a:pPr lvl="1"/>
@@ -956,7 +973,6 @@
               <a:rPr lang="zh-CN" altLang="en-US" dirty="0"/>
               <a:t>Second level</a:t>
             </a:r>
-            <a:endParaRPr lang="zh-CN" altLang="en-US" dirty="0"/>
           </a:p>
           <a:p>
             <a:pPr lvl="2"/>
@@ -964,7 +980,6 @@
               <a:rPr lang="zh-CN" altLang="en-US" dirty="0"/>
               <a:t>Third level</a:t>
             </a:r>
-            <a:endParaRPr lang="zh-CN" altLang="en-US" dirty="0"/>
           </a:p>
           <a:p>
             <a:pPr lvl="3"/>
@@ -972,7 +987,6 @@
               <a:rPr lang="zh-CN" altLang="en-US" dirty="0"/>
               <a:t>Fourth level</a:t>
             </a:r>
-            <a:endParaRPr lang="zh-CN" altLang="en-US" dirty="0"/>
           </a:p>
           <a:p>
             <a:pPr lvl="4"/>
@@ -980,7 +994,6 @@
               <a:rPr lang="zh-CN" altLang="en-US" dirty="0"/>
               <a:t>Fifth level</a:t>
             </a:r>
-            <a:endParaRPr lang="zh-CN" altLang="en-US" dirty="0"/>
           </a:p>
         </p:txBody>
       </p:sp>
@@ -1047,7 +1060,6 @@
               <a:rPr lang="zh-CN" altLang="en-US" dirty="0"/>
               <a:t>Click to edit Master title style</a:t>
             </a:r>
-            <a:endParaRPr lang="zh-CN" altLang="en-US" dirty="0"/>
           </a:p>
         </p:txBody>
       </p:sp>
@@ -1131,9 +1143,6 @@
               </a:rPr>
               <a:t>Click to edit Master text styles</a:t>
             </a:r>
-            <a:endParaRPr lang="zh-CN" altLang="en-US" dirty="0">
-              <a:sym typeface="+mn-ea"/>
-            </a:endParaRPr>
           </a:p>
           <a:p>
             <a:pPr lvl="1"/>
@@ -1141,7 +1150,6 @@
               <a:rPr lang="zh-CN" altLang="en-US" dirty="0"/>
               <a:t>Second level</a:t>
             </a:r>
-            <a:endParaRPr lang="zh-CN" altLang="en-US" dirty="0"/>
           </a:p>
           <a:p>
             <a:pPr lvl="2"/>
@@ -1149,7 +1157,6 @@
               <a:rPr lang="zh-CN" altLang="en-US" dirty="0"/>
               <a:t>Third level</a:t>
             </a:r>
-            <a:endParaRPr lang="zh-CN" altLang="en-US" dirty="0"/>
           </a:p>
           <a:p>
             <a:pPr lvl="3"/>
@@ -1157,7 +1164,6 @@
               <a:rPr lang="zh-CN" altLang="en-US" dirty="0"/>
               <a:t>Fourth level</a:t>
             </a:r>
-            <a:endParaRPr lang="zh-CN" altLang="en-US" dirty="0"/>
           </a:p>
           <a:p>
             <a:pPr lvl="4"/>
@@ -1165,7 +1171,6 @@
               <a:rPr lang="zh-CN" altLang="en-US" dirty="0"/>
               <a:t>Fifth level</a:t>
             </a:r>
-            <a:endParaRPr lang="zh-CN" altLang="en-US" dirty="0"/>
           </a:p>
         </p:txBody>
       </p:sp>
@@ -1186,6 +1191,7 @@
           <a:p>
             <a:fld id="{760FBDFE-C587-4B4C-A407-44438C67B59E}" type="datetimeFigureOut">
               <a:rPr lang="zh-CN" altLang="en-US" smtClean="0"/>
+              <a:t>2026/10/22</a:t>
             </a:fld>
             <a:endParaRPr lang="zh-CN" altLang="en-US"/>
           </a:p>
@@ -1227,6 +1233,7 @@
           <a:p>
             <a:fld id="{49AE70B2-8BF9-45C0-BB95-33D1B9D3A854}" type="slidenum">
               <a:rPr lang="zh-CN" altLang="en-US" smtClean="0"/>
+              <a:t>‹#›</a:t>
             </a:fld>
             <a:endParaRPr lang="zh-CN" altLang="en-US"/>
           </a:p>
@@ -1295,7 +1302,6 @@
               <a:rPr lang="zh-CN" altLang="en-US" dirty="0"/>
               <a:t>Click to edit Master title style</a:t>
             </a:r>
-            <a:endParaRPr lang="zh-CN" altLang="en-US" dirty="0"/>
           </a:p>
         </p:txBody>
       </p:sp>
@@ -1417,9 +1423,6 @@
               </a:rPr>
               <a:t>Click to edit Master text styles</a:t>
             </a:r>
-            <a:endParaRPr lang="zh-CN" altLang="en-US" dirty="0">
-              <a:sym typeface="+mn-ea"/>
-            </a:endParaRPr>
           </a:p>
         </p:txBody>
       </p:sp>
@@ -1440,6 +1443,7 @@
           <a:p>
             <a:fld id="{760FBDFE-C587-4B4C-A407-44438C67B59E}" type="datetimeFigureOut">
               <a:rPr lang="zh-CN" altLang="en-US" smtClean="0"/>
+              <a:t>2026/10/22</a:t>
             </a:fld>
             <a:endParaRPr lang="zh-CN" altLang="en-US"/>
           </a:p>
@@ -1481,6 +1485,7 @@
           <a:p>
             <a:fld id="{49AE70B2-8BF9-45C0-BB95-33D1B9D3A854}" type="slidenum">
               <a:rPr lang="zh-CN" altLang="en-US" smtClean="0"/>
+              <a:t>‹#›</a:t>
             </a:fld>
             <a:endParaRPr lang="zh-CN" altLang="en-US"/>
           </a:p>
@@ -1549,7 +1554,6 @@
               <a:rPr lang="zh-CN" altLang="en-US" dirty="0"/>
               <a:t>Click to edit Master title style</a:t>
             </a:r>
-            <a:endParaRPr lang="zh-CN" altLang="en-US" dirty="0"/>
           </a:p>
         </p:txBody>
       </p:sp>
@@ -1648,9 +1652,6 @@
               </a:rPr>
               <a:t>Click to edit Master text styles</a:t>
             </a:r>
-            <a:endParaRPr lang="zh-CN" altLang="en-US" dirty="0">
-              <a:sym typeface="+mn-ea"/>
-            </a:endParaRPr>
           </a:p>
           <a:p>
             <a:pPr lvl="1"/>
@@ -1658,7 +1659,6 @@
               <a:rPr lang="zh-CN" altLang="en-US" dirty="0"/>
               <a:t>Second level</a:t>
             </a:r>
-            <a:endParaRPr lang="zh-CN" altLang="en-US" dirty="0"/>
           </a:p>
           <a:p>
             <a:pPr lvl="2"/>
@@ -1666,7 +1666,6 @@
               <a:rPr lang="zh-CN" altLang="en-US" dirty="0"/>
               <a:t>Third level</a:t>
             </a:r>
-            <a:endParaRPr lang="zh-CN" altLang="en-US" dirty="0"/>
           </a:p>
           <a:p>
             <a:pPr lvl="3"/>
@@ -1674,7 +1673,6 @@
               <a:rPr lang="zh-CN" altLang="en-US" dirty="0"/>
               <a:t>Fourth level</a:t>
             </a:r>
-            <a:endParaRPr lang="zh-CN" altLang="en-US" dirty="0"/>
           </a:p>
           <a:p>
             <a:pPr lvl="4"/>
@@ -1682,7 +1680,6 @@
               <a:rPr lang="zh-CN" altLang="en-US" dirty="0"/>
               <a:t>Fifth level</a:t>
             </a:r>
-            <a:endParaRPr lang="zh-CN" altLang="en-US" dirty="0"/>
           </a:p>
         </p:txBody>
       </p:sp>
@@ -1781,9 +1778,6 @@
               </a:rPr>
               <a:t>Click to edit Master text styles</a:t>
             </a:r>
-            <a:endParaRPr lang="zh-CN" altLang="en-US" dirty="0">
-              <a:sym typeface="+mn-ea"/>
-            </a:endParaRPr>
           </a:p>
           <a:p>
             <a:pPr lvl="1"/>
@@ -1791,7 +1785,6 @@
               <a:rPr lang="zh-CN" altLang="en-US" dirty="0"/>
               <a:t>Second level</a:t>
             </a:r>
-            <a:endParaRPr lang="zh-CN" altLang="en-US" dirty="0"/>
           </a:p>
           <a:p>
             <a:pPr lvl="2"/>
@@ -1799,7 +1792,6 @@
               <a:rPr lang="zh-CN" altLang="en-US" dirty="0"/>
               <a:t>Third level</a:t>
             </a:r>
-            <a:endParaRPr lang="zh-CN" altLang="en-US" dirty="0"/>
           </a:p>
           <a:p>
             <a:pPr lvl="3"/>
@@ -1807,7 +1799,6 @@
               <a:rPr lang="zh-CN" altLang="en-US" dirty="0"/>
               <a:t>Fourth level</a:t>
             </a:r>
-            <a:endParaRPr lang="zh-CN" altLang="en-US" dirty="0"/>
           </a:p>
           <a:p>
             <a:pPr lvl="4"/>
@@ -1815,7 +1806,6 @@
               <a:rPr lang="zh-CN" altLang="en-US" dirty="0"/>
               <a:t>Fifth level</a:t>
             </a:r>
-            <a:endParaRPr lang="zh-CN" altLang="en-US" dirty="0"/>
           </a:p>
         </p:txBody>
       </p:sp>
@@ -1836,6 +1826,7 @@
           <a:p>
             <a:fld id="{760FBDFE-C587-4B4C-A407-44438C67B59E}" type="datetimeFigureOut">
               <a:rPr lang="zh-CN" altLang="en-US" smtClean="0"/>
+              <a:t>2026/10/22</a:t>
             </a:fld>
             <a:endParaRPr lang="zh-CN" altLang="en-US"/>
           </a:p>
@@ -1877,6 +1868,7 @@
           <a:p>
             <a:fld id="{49AE70B2-8BF9-45C0-BB95-33D1B9D3A854}" type="slidenum">
               <a:rPr lang="zh-CN" altLang="en-US" smtClean="0"/>
+              <a:t>‹#›</a:t>
             </a:fld>
             <a:endParaRPr lang="zh-CN" altLang="en-US"/>
           </a:p>
@@ -1931,7 +1923,6 @@
               <a:rPr lang="zh-CN" altLang="en-US"/>
               <a:t>Click to edit Master title style</a:t>
             </a:r>
-            <a:endParaRPr lang="zh-CN" altLang="en-US"/>
           </a:p>
         </p:txBody>
       </p:sp>
@@ -1999,9 +1990,6 @@
               </a:rPr>
               <a:t>Click to edit Master text styles</a:t>
             </a:r>
-            <a:endParaRPr lang="zh-CN" altLang="en-US" dirty="0">
-              <a:sym typeface="+mn-ea"/>
-            </a:endParaRPr>
           </a:p>
         </p:txBody>
       </p:sp>
@@ -2032,9 +2020,6 @@
               </a:rPr>
               <a:t>Click to edit Master text styles</a:t>
             </a:r>
-            <a:endParaRPr lang="zh-CN" altLang="en-US" dirty="0">
-              <a:sym typeface="+mn-ea"/>
-            </a:endParaRPr>
           </a:p>
           <a:p>
             <a:pPr lvl="1"/>
@@ -2042,7 +2027,6 @@
               <a:rPr lang="zh-CN" altLang="en-US" dirty="0"/>
               <a:t>Second level</a:t>
             </a:r>
-            <a:endParaRPr lang="zh-CN" altLang="en-US" dirty="0"/>
           </a:p>
           <a:p>
             <a:pPr lvl="2"/>
@@ -2050,7 +2034,6 @@
               <a:rPr lang="zh-CN" altLang="en-US" dirty="0"/>
               <a:t>Third level</a:t>
             </a:r>
-            <a:endParaRPr lang="zh-CN" altLang="en-US" dirty="0"/>
           </a:p>
           <a:p>
             <a:pPr lvl="3"/>
@@ -2058,7 +2041,6 @@
               <a:rPr lang="zh-CN" altLang="en-US" dirty="0"/>
               <a:t>Fourth level</a:t>
             </a:r>
-            <a:endParaRPr lang="zh-CN" altLang="en-US" dirty="0"/>
           </a:p>
           <a:p>
             <a:pPr lvl="4"/>
@@ -2066,7 +2048,6 @@
               <a:rPr lang="zh-CN" altLang="en-US" dirty="0"/>
               <a:t>Fifth level</a:t>
             </a:r>
-            <a:endParaRPr lang="zh-CN" altLang="en-US" dirty="0"/>
           </a:p>
         </p:txBody>
       </p:sp>
@@ -2134,9 +2115,6 @@
               </a:rPr>
               <a:t>Click to edit Master text styles</a:t>
             </a:r>
-            <a:endParaRPr lang="zh-CN" altLang="en-US" dirty="0">
-              <a:sym typeface="+mn-ea"/>
-            </a:endParaRPr>
           </a:p>
         </p:txBody>
       </p:sp>
@@ -2167,9 +2145,6 @@
               </a:rPr>
               <a:t>Click to edit Master text styles</a:t>
             </a:r>
-            <a:endParaRPr lang="zh-CN" altLang="en-US" dirty="0">
-              <a:sym typeface="+mn-ea"/>
-            </a:endParaRPr>
           </a:p>
           <a:p>
             <a:pPr lvl="1"/>
@@ -2177,7 +2152,6 @@
               <a:rPr lang="zh-CN" altLang="en-US" dirty="0"/>
               <a:t>Second level</a:t>
             </a:r>
-            <a:endParaRPr lang="zh-CN" altLang="en-US" dirty="0"/>
           </a:p>
           <a:p>
             <a:pPr lvl="2"/>
@@ -2185,7 +2159,6 @@
               <a:rPr lang="zh-CN" altLang="en-US" dirty="0"/>
               <a:t>Third level</a:t>
             </a:r>
-            <a:endParaRPr lang="zh-CN" altLang="en-US" dirty="0"/>
           </a:p>
           <a:p>
             <a:pPr lvl="3"/>
@@ -2193,7 +2166,6 @@
               <a:rPr lang="zh-CN" altLang="en-US" dirty="0"/>
               <a:t>Fourth level</a:t>
             </a:r>
-            <a:endParaRPr lang="zh-CN" altLang="en-US" dirty="0"/>
           </a:p>
           <a:p>
             <a:pPr lvl="4"/>
@@ -2201,7 +2173,6 @@
               <a:rPr lang="zh-CN" altLang="en-US" dirty="0"/>
               <a:t>Fifth level</a:t>
             </a:r>
-            <a:endParaRPr lang="zh-CN" altLang="en-US" dirty="0"/>
           </a:p>
         </p:txBody>
       </p:sp>
@@ -2222,6 +2193,7 @@
           <a:p>
             <a:fld id="{760FBDFE-C587-4B4C-A407-44438C67B59E}" type="datetimeFigureOut">
               <a:rPr lang="zh-CN" altLang="en-US" smtClean="0"/>
+              <a:t>2026/10/22</a:t>
             </a:fld>
             <a:endParaRPr lang="zh-CN" altLang="en-US"/>
           </a:p>
@@ -2263,6 +2235,7 @@
           <a:p>
             <a:fld id="{49AE70B2-8BF9-45C0-BB95-33D1B9D3A854}" type="slidenum">
               <a:rPr lang="zh-CN" altLang="en-US" smtClean="0"/>
+              <a:t>‹#›</a:t>
             </a:fld>
             <a:endParaRPr lang="zh-CN" altLang="en-US"/>
           </a:p>
@@ -2331,7 +2304,6 @@
               <a:rPr lang="zh-CN" altLang="en-US" dirty="0"/>
               <a:t>Click to edit Master title style</a:t>
             </a:r>
-            <a:endParaRPr lang="zh-CN" altLang="en-US" dirty="0"/>
           </a:p>
         </p:txBody>
       </p:sp>
@@ -2352,6 +2324,7 @@
           <a:p>
             <a:fld id="{760FBDFE-C587-4B4C-A407-44438C67B59E}" type="datetimeFigureOut">
               <a:rPr lang="zh-CN" altLang="en-US" smtClean="0"/>
+              <a:t>2026/10/22</a:t>
             </a:fld>
             <a:endParaRPr lang="zh-CN" altLang="en-US"/>
           </a:p>
@@ -2393,6 +2366,7 @@
           <a:p>
             <a:fld id="{49AE70B2-8BF9-45C0-BB95-33D1B9D3A854}" type="slidenum">
               <a:rPr lang="zh-CN" altLang="en-US" smtClean="0"/>
+              <a:t>‹#›</a:t>
             </a:fld>
             <a:endParaRPr lang="zh-CN" altLang="en-US"/>
           </a:p>
@@ -2440,6 +2414,7 @@
           <a:p>
             <a:fld id="{760FBDFE-C587-4B4C-A407-44438C67B59E}" type="datetimeFigureOut">
               <a:rPr lang="zh-CN" altLang="en-US" smtClean="0"/>
+              <a:t>2026/10/22</a:t>
             </a:fld>
             <a:endParaRPr lang="zh-CN" altLang="en-US"/>
           </a:p>
@@ -2481,6 +2456,7 @@
           <a:p>
             <a:fld id="{49AE70B2-8BF9-45C0-BB95-33D1B9D3A854}" type="slidenum">
               <a:rPr lang="zh-CN" altLang="en-US" smtClean="0"/>
+              <a:t>‹#›</a:t>
             </a:fld>
             <a:endParaRPr lang="zh-CN" altLang="en-US"/>
           </a:p>
@@ -2551,9 +2527,6 @@
               </a:rPr>
               <a:t>Click to edit Master title style</a:t>
             </a:r>
-            <a:endParaRPr lang="zh-CN" altLang="en-US" dirty="0">
-              <a:sym typeface="+mn-ea"/>
-            </a:endParaRPr>
           </a:p>
         </p:txBody>
       </p:sp>
@@ -2685,7 +2658,6 @@
               <a:rPr lang="zh-CN" altLang="en-US" dirty="0"/>
               <a:t>Click to edit Master text styles</a:t>
             </a:r>
-            <a:endParaRPr lang="zh-CN" altLang="en-US" dirty="0"/>
           </a:p>
         </p:txBody>
       </p:sp>
@@ -2706,6 +2678,7 @@
           <a:p>
             <a:fld id="{9EFD9D74-47D9-4702-A33C-335B63B48DBF}" type="datetimeFigureOut">
               <a:rPr lang="zh-CN" altLang="en-US" smtClean="0"/>
+              <a:t>2026/10/22</a:t>
             </a:fld>
             <a:endParaRPr lang="zh-CN" altLang="en-US" dirty="0"/>
           </a:p>
@@ -2747,6 +2720,7 @@
           <a:p>
             <a:fld id="{FABC47A4-756D-490B-A52F-7D9E2C9FC05F}" type="slidenum">
               <a:rPr lang="zh-CN" altLang="en-US" smtClean="0"/>
+              <a:t>‹#›</a:t>
             </a:fld>
             <a:endParaRPr lang="zh-CN" altLang="en-US"/>
           </a:p>
@@ -2837,7 +2811,6 @@
               <a:rPr lang="zh-CN" altLang="en-US"/>
               <a:t>Click to edit Master title style</a:t>
             </a:r>
-            <a:endParaRPr lang="zh-CN" altLang="en-US"/>
           </a:p>
         </p:txBody>
       </p:sp>
@@ -2868,9 +2841,6 @@
               </a:rPr>
               <a:t>Click to edit Master text styles</a:t>
             </a:r>
-            <a:endParaRPr lang="zh-CN" altLang="en-US" dirty="0">
-              <a:sym typeface="+mn-ea"/>
-            </a:endParaRPr>
           </a:p>
           <a:p>
             <a:pPr lvl="1"/>
@@ -2878,7 +2848,6 @@
               <a:rPr lang="zh-CN" altLang="en-US" dirty="0"/>
               <a:t>Second level</a:t>
             </a:r>
-            <a:endParaRPr lang="zh-CN" altLang="en-US" dirty="0"/>
           </a:p>
           <a:p>
             <a:pPr lvl="2"/>
@@ -2886,7 +2855,6 @@
               <a:rPr lang="zh-CN" altLang="en-US" dirty="0"/>
               <a:t>Third level</a:t>
             </a:r>
-            <a:endParaRPr lang="zh-CN" altLang="en-US" dirty="0"/>
           </a:p>
           <a:p>
             <a:pPr lvl="3"/>
@@ -2894,7 +2862,6 @@
               <a:rPr lang="zh-CN" altLang="en-US" dirty="0"/>
               <a:t>Fourth level</a:t>
             </a:r>
-            <a:endParaRPr lang="zh-CN" altLang="en-US" dirty="0"/>
           </a:p>
           <a:p>
             <a:pPr lvl="4"/>
@@ -2902,7 +2869,6 @@
               <a:rPr lang="zh-CN" altLang="en-US" dirty="0"/>
               <a:t>Fifth level</a:t>
             </a:r>
-            <a:endParaRPr lang="zh-CN" altLang="en-US" dirty="0"/>
           </a:p>
         </p:txBody>
       </p:sp>
@@ -2923,6 +2889,7 @@
           <a:p>
             <a:fld id="{760FBDFE-C587-4B4C-A407-44438C67B59E}" type="datetimeFigureOut">
               <a:rPr lang="zh-CN" altLang="en-US" smtClean="0"/>
+              <a:t>2026/10/22</a:t>
             </a:fld>
             <a:endParaRPr lang="zh-CN" altLang="en-US"/>
           </a:p>
@@ -2964,6 +2931,7 @@
           <a:p>
             <a:fld id="{49AE70B2-8BF9-45C0-BB95-33D1B9D3A854}" type="slidenum">
               <a:rPr lang="zh-CN" altLang="en-US" smtClean="0"/>
+              <a:t>‹#›</a:t>
             </a:fld>
             <a:endParaRPr lang="zh-CN" altLang="en-US"/>
           </a:p>
@@ -3031,7 +2999,6 @@
               <a:rPr lang="zh-CN" altLang="en-US" dirty="0"/>
               <a:t>Click to edit Master title style</a:t>
             </a:r>
-            <a:endParaRPr lang="zh-CN" altLang="en-US" dirty="0"/>
           </a:p>
         </p:txBody>
       </p:sp>
@@ -3067,9 +3034,6 @@
               </a:rPr>
               <a:t>Click to edit Master text styles</a:t>
             </a:r>
-            <a:endParaRPr lang="zh-CN" altLang="en-US" dirty="0">
-              <a:sym typeface="+mn-ea"/>
-            </a:endParaRPr>
           </a:p>
           <a:p>
             <a:pPr lvl="1"/>
@@ -3077,7 +3041,6 @@
               <a:rPr lang="zh-CN" altLang="en-US" dirty="0"/>
               <a:t>Second level</a:t>
             </a:r>
-            <a:endParaRPr lang="zh-CN" altLang="en-US" dirty="0"/>
           </a:p>
           <a:p>
             <a:pPr lvl="2"/>
@@ -3085,7 +3048,6 @@
               <a:rPr lang="zh-CN" altLang="en-US" dirty="0"/>
               <a:t>Third level</a:t>
             </a:r>
-            <a:endParaRPr lang="zh-CN" altLang="en-US" dirty="0"/>
           </a:p>
           <a:p>
             <a:pPr lvl="3"/>
@@ -3093,7 +3055,6 @@
               <a:rPr lang="zh-CN" altLang="en-US" dirty="0"/>
               <a:t>Fourth level</a:t>
             </a:r>
-            <a:endParaRPr lang="zh-CN" altLang="en-US" dirty="0"/>
           </a:p>
           <a:p>
             <a:pPr lvl="4"/>
@@ -3101,7 +3062,6 @@
               <a:rPr lang="zh-CN" altLang="en-US" dirty="0"/>
               <a:t>Fifth level</a:t>
             </a:r>
-            <a:endParaRPr lang="zh-CN" altLang="en-US" dirty="0"/>
           </a:p>
         </p:txBody>
       </p:sp>
@@ -3142,6 +3102,7 @@
           <a:p>
             <a:fld id="{760FBDFE-C587-4B4C-A407-44438C67B59E}" type="datetimeFigureOut">
               <a:rPr lang="zh-CN" altLang="en-US" smtClean="0"/>
+              <a:t>2026/10/22</a:t>
             </a:fld>
             <a:endParaRPr lang="zh-CN" altLang="en-US"/>
           </a:p>
@@ -3223,6 +3184,7 @@
           <a:p>
             <a:fld id="{49AE70B2-8BF9-45C0-BB95-33D1B9D3A854}" type="slidenum">
               <a:rPr lang="zh-CN" altLang="en-US" smtClean="0"/>
+              <a:t>‹#›</a:t>
             </a:fld>
             <a:endParaRPr lang="zh-CN" altLang="en-US"/>
           </a:p>
@@ -3535,7 +3497,14 @@
         <p:cNvGrpSpPr/>
         <p:nvPr/>
       </p:nvGrpSpPr>
-      <p:grpSpPr/>
+      <p:grpSpPr>
+        <a:xfrm>
+          <a:off x="0" y="0"/>
+          <a:ext cx="0" cy="0"/>
+          <a:chOff x="0" y="0"/>
+          <a:chExt cx="0" cy="0"/>
+        </a:xfrm>
+      </p:grpSpPr>
       <p:sp>
         <p:nvSpPr>
           <p:cNvPr id="4" name="标题 1"/>
@@ -3564,7 +3533,7 @@
               </a:lnSpc>
             </a:pPr>
             <a:r>
-              <a:rPr lang="en-US" altLang="en-US" sz="3600" i="1">
+              <a:rPr lang="en-US" altLang="en-US" sz="3600" i="1" dirty="0">
                 <a:solidFill>
                   <a:srgbClr val="000000"/>
                 </a:solidFill>
@@ -3575,7 +3544,7 @@
               <a:t>Machine Learning Street Talk</a:t>
             </a:r>
             <a:br>
-              <a:rPr lang="en-US" altLang="en-US" sz="3600" i="1">
+              <a:rPr lang="en-US" altLang="en-US" sz="3600" i="1" dirty="0">
                 <a:solidFill>
                   <a:srgbClr val="000000"/>
                 </a:solidFill>
@@ -3585,7 +3554,7 @@
               </a:rPr>
             </a:br>
             <a:br>
-              <a:rPr lang="en-US" altLang="en-US" sz="1200" i="1">
+              <a:rPr lang="en-US" altLang="en-US" sz="1200" i="1" dirty="0">
                 <a:solidFill>
                   <a:srgbClr val="000000"/>
                 </a:solidFill>
@@ -3595,7 +3564,7 @@
               </a:rPr>
             </a:br>
             <a:br>
-              <a:rPr lang="en-US" altLang="en-US" sz="2000" i="1">
+              <a:rPr lang="en-US" altLang="en-US" sz="2000" i="1" dirty="0">
                 <a:solidFill>
                   <a:srgbClr val="000000"/>
                 </a:solidFill>
@@ -3605,7 +3574,7 @@
               </a:rPr>
             </a:br>
             <a:r>
-              <a:rPr lang="en-US" altLang="en-US" sz="2000" i="1">
+              <a:rPr lang="en-US" altLang="en-US" sz="2000" i="1" dirty="0">
                 <a:solidFill>
                   <a:srgbClr val="000000"/>
                 </a:solidFill>
@@ -3615,14 +3584,6 @@
               </a:rPr>
               <a:t>The MLP Assumption, Inductive Biases, Self-organizing/Coordinating Networks</a:t>
             </a:r>
-            <a:endParaRPr lang="en-US" altLang="en-US" sz="2000" i="1">
-              <a:solidFill>
-                <a:srgbClr val="000000"/>
-              </a:solidFill>
-              <a:latin typeface="FreeSerif" panose="02020603050405020304"/>
-              <a:ea typeface="Roboto" panose="02000000000000000000"/>
-              <a:cs typeface="Roboto" panose="02000000000000000000"/>
-            </a:endParaRPr>
           </a:p>
         </p:txBody>
       </p:sp>
@@ -3654,11 +3615,6 @@
               </a:rPr>
               <a:t>Emmanuel Olateju</a:t>
             </a:r>
-            <a:endParaRPr lang="x-none" altLang="zh-CN" b="1" i="1">
-              <a:latin typeface="FreeSerif" panose="02020603050405020304"/>
-              <a:ea typeface="等线"/>
-              <a:cs typeface="FreeSerif" panose="02020603050405020304" charset="0"/>
-            </a:endParaRPr>
           </a:p>
         </p:txBody>
       </p:sp>
@@ -3682,6 +3638,7 @@
           <a:bodyPr wrap="none" rtlCol="0">
             <a:spAutoFit/>
           </a:bodyPr>
+          <a:lstStyle/>
           <a:p>
             <a:pPr algn="ctr"/>
             <a:r>
@@ -3691,10 +3648,6 @@
               </a:rPr>
               <a:t>Presented By</a:t>
             </a:r>
-            <a:endParaRPr lang="en-US" sz="1000" i="1">
-              <a:latin typeface="FreeSerif" panose="02020603050405020304" charset="0"/>
-              <a:cs typeface="FreeSerif" panose="02020603050405020304" charset="0"/>
-            </a:endParaRPr>
           </a:p>
         </p:txBody>
       </p:sp>
@@ -3715,7 +3668,14 @@
         <p:cNvGrpSpPr/>
         <p:nvPr/>
       </p:nvGrpSpPr>
-      <p:grpSpPr/>
+      <p:grpSpPr>
+        <a:xfrm>
+          <a:off x="0" y="0"/>
+          <a:ext cx="0" cy="0"/>
+          <a:chOff x="0" y="0"/>
+          <a:chExt cx="0" cy="0"/>
+        </a:xfrm>
+      </p:grpSpPr>
       <p:sp>
         <p:nvSpPr>
           <p:cNvPr id="7" name="Text Box 6"/>
@@ -3745,9 +3705,6 @@
               </a:rPr>
               <a:t>The MLP Assumption</a:t>
             </a:r>
-            <a:endParaRPr lang="en-US" altLang="en-US" b="1" i="1" dirty="0">
-              <a:latin typeface="FreeSerif" panose="02020603050405020304"/>
-            </a:endParaRPr>
           </a:p>
         </p:txBody>
       </p:sp>
@@ -3760,7 +3717,7 @@
           <p:nvPr/>
         </p:nvPicPr>
         <p:blipFill>
-          <a:blip r:embed="rId1"/>
+          <a:blip r:embed="rId2"/>
           <a:stretch>
             <a:fillRect/>
           </a:stretch>
@@ -3797,6 +3754,7 @@
           <a:bodyPr wrap="square" rtlCol="0">
             <a:spAutoFit/>
           </a:bodyPr>
+          <a:lstStyle/>
           <a:p>
             <a:pPr algn="ctr"/>
             <a:r>
@@ -3809,13 +3767,6 @@
               </a:rPr>
               <a:t>MLP</a:t>
             </a:r>
-            <a:endParaRPr lang="en-US" altLang="en-US">
-              <a:solidFill>
-                <a:schemeClr val="bg1"/>
-              </a:solidFill>
-              <a:latin typeface="FreeSerif" panose="02020603050405020304" charset="0"/>
-              <a:cs typeface="FreeSerif" panose="02020603050405020304" charset="0"/>
-            </a:endParaRPr>
           </a:p>
         </p:txBody>
       </p:sp>
@@ -3841,6 +3792,7 @@
           <a:bodyPr wrap="square" rtlCol="0">
             <a:spAutoFit/>
           </a:bodyPr>
+          <a:lstStyle/>
           <a:p>
             <a:pPr algn="ctr"/>
             <a:r>
@@ -3853,13 +3805,6 @@
               </a:rPr>
               <a:t>KAN</a:t>
             </a:r>
-            <a:endParaRPr lang="en-US" altLang="en-US">
-              <a:solidFill>
-                <a:schemeClr val="bg1"/>
-              </a:solidFill>
-              <a:latin typeface="FreeSerif" panose="02020603050405020304" charset="0"/>
-              <a:cs typeface="FreeSerif" panose="02020603050405020304" charset="0"/>
-            </a:endParaRPr>
           </a:p>
         </p:txBody>
       </p:sp>
@@ -3888,6 +3833,7 @@
           <a:bodyPr wrap="square" rtlCol="0">
             <a:spAutoFit/>
           </a:bodyPr>
+          <a:lstStyle/>
           <a:p>
             <a:r>
               <a:rPr lang="en-US" altLang="en-US" sz="1000">
@@ -3896,10 +3842,6 @@
               </a:rPr>
               <a:t>Linear weights on edges</a:t>
             </a:r>
-            <a:endParaRPr lang="en-US" altLang="en-US" sz="1000">
-              <a:latin typeface="FreeSerif" panose="02020603050405020304" charset="0"/>
-              <a:cs typeface="FreeSerif" panose="02020603050405020304" charset="0"/>
-            </a:endParaRPr>
           </a:p>
         </p:txBody>
       </p:sp>
@@ -3928,6 +3870,7 @@
           <a:bodyPr wrap="square" rtlCol="0">
             <a:spAutoFit/>
           </a:bodyPr>
+          <a:lstStyle/>
           <a:p>
             <a:r>
               <a:rPr lang="en-US" altLang="en-US" sz="1000">
@@ -3949,10 +3892,6 @@
               </a:rPr>
               <a:t>nodes</a:t>
             </a:r>
-            <a:endParaRPr lang="en-US" altLang="en-US" sz="1000">
-              <a:latin typeface="FreeSerif" panose="02020603050405020304" charset="0"/>
-              <a:cs typeface="FreeSerif" panose="02020603050405020304" charset="0"/>
-            </a:endParaRPr>
           </a:p>
         </p:txBody>
       </p:sp>
@@ -4054,6 +3993,7 @@
           <a:bodyPr wrap="square" rtlCol="0">
             <a:spAutoFit/>
           </a:bodyPr>
+          <a:lstStyle/>
           <a:p>
             <a:r>
               <a:rPr lang="en-US" altLang="en-US" sz="1000">
@@ -4062,10 +4002,6 @@
               </a:rPr>
               <a:t>Learnable activation     </a:t>
             </a:r>
-            <a:endParaRPr lang="en-US" altLang="en-US" sz="1000">
-              <a:latin typeface="FreeSerif" panose="02020603050405020304" charset="0"/>
-              <a:cs typeface="FreeSerif" panose="02020603050405020304" charset="0"/>
-            </a:endParaRPr>
           </a:p>
           <a:p>
             <a:r>
@@ -4075,10 +4011,6 @@
               </a:rPr>
               <a:t>functions on edges</a:t>
             </a:r>
-            <a:endParaRPr lang="en-US" altLang="en-US" sz="1000">
-              <a:latin typeface="FreeSerif" panose="02020603050405020304" charset="0"/>
-              <a:cs typeface="FreeSerif" panose="02020603050405020304" charset="0"/>
-            </a:endParaRPr>
           </a:p>
         </p:txBody>
       </p:sp>
@@ -4107,6 +4039,7 @@
           <a:bodyPr wrap="square" rtlCol="0">
             <a:spAutoFit/>
           </a:bodyPr>
+          <a:lstStyle/>
           <a:p>
             <a:r>
               <a:rPr lang="en-US" altLang="en-US" sz="1000">
@@ -4141,10 +4074,6 @@
               </a:rPr>
               <a:t>non-linearitues</a:t>
             </a:r>
-            <a:endParaRPr lang="en-US" altLang="en-US" sz="1000">
-              <a:latin typeface="FreeSerif" panose="02020603050405020304" charset="0"/>
-              <a:cs typeface="FreeSerif" panose="02020603050405020304" charset="0"/>
-            </a:endParaRPr>
           </a:p>
         </p:txBody>
       </p:sp>
@@ -4252,6 +4181,7 @@
           <a:bodyPr wrap="none" rtlCol="0">
             <a:spAutoFit/>
           </a:bodyPr>
+          <a:lstStyle/>
           <a:p>
             <a:pPr algn="ctr"/>
             <a:r>
@@ -4283,13 +4213,6 @@
               </a:rPr>
               <a:t>PLASTICITY</a:t>
             </a:r>
-            <a:endParaRPr lang="en-US" altLang="en-US" sz="1400">
-              <a:solidFill>
-                <a:schemeClr val="bg1"/>
-              </a:solidFill>
-              <a:latin typeface="FreeSerif" panose="02020603050405020304" charset="0"/>
-              <a:cs typeface="FreeSerif" panose="02020603050405020304" charset="0"/>
-            </a:endParaRPr>
           </a:p>
         </p:txBody>
       </p:sp>
@@ -4320,6 +4243,7 @@
           <a:bodyPr wrap="square" rtlCol="0">
             <a:spAutoFit/>
           </a:bodyPr>
+          <a:lstStyle/>
           <a:p>
             <a:pPr algn="ctr"/>
             <a:r>
@@ -4332,13 +4256,6 @@
               </a:rPr>
               <a:t>Localized B-spline updates</a:t>
             </a:r>
-            <a:endParaRPr lang="en-US" altLang="en-US" sz="1200">
-              <a:solidFill>
-                <a:schemeClr val="bg1"/>
-              </a:solidFill>
-              <a:latin typeface="FreeSerif" panose="02020603050405020304" charset="0"/>
-              <a:cs typeface="FreeSerif" panose="02020603050405020304" charset="0"/>
-            </a:endParaRPr>
           </a:p>
         </p:txBody>
       </p:sp>
@@ -4369,6 +4286,7 @@
           <a:bodyPr wrap="none" rtlCol="0">
             <a:spAutoFit/>
           </a:bodyPr>
+          <a:lstStyle/>
           <a:p>
             <a:pPr algn="ctr"/>
             <a:r>
@@ -4400,13 +4318,6 @@
               </a:rPr>
               <a:t>Activations</a:t>
             </a:r>
-            <a:endParaRPr lang="en-US" altLang="en-US" sz="1200">
-              <a:solidFill>
-                <a:schemeClr val="bg1"/>
-              </a:solidFill>
-              <a:latin typeface="FreeSerif" panose="02020603050405020304" charset="0"/>
-              <a:cs typeface="FreeSerif" panose="02020603050405020304" charset="0"/>
-            </a:endParaRPr>
           </a:p>
         </p:txBody>
       </p:sp>
@@ -4419,7 +4330,7 @@
           <p:nvPr/>
         </p:nvPicPr>
         <p:blipFill>
-          <a:blip r:embed="rId2"/>
+          <a:blip r:embed="rId3"/>
           <a:stretch>
             <a:fillRect/>
           </a:stretch>
@@ -4461,6 +4372,7 @@
           <a:bodyPr wrap="none" rtlCol="0">
             <a:spAutoFit/>
           </a:bodyPr>
+          <a:lstStyle/>
           <a:p>
             <a:pPr algn="ctr"/>
             <a:r>
@@ -4492,13 +4404,6 @@
               </a:rPr>
               <a:t>STRUCTURE</a:t>
             </a:r>
-            <a:endParaRPr lang="en-US" altLang="en-US" sz="1400">
-              <a:solidFill>
-                <a:schemeClr val="bg1"/>
-              </a:solidFill>
-              <a:latin typeface="FreeSerif" panose="02020603050405020304" charset="0"/>
-              <a:cs typeface="FreeSerif" panose="02020603050405020304" charset="0"/>
-            </a:endParaRPr>
           </a:p>
         </p:txBody>
       </p:sp>
@@ -4529,6 +4434,7 @@
           <a:bodyPr wrap="square" rtlCol="0">
             <a:spAutoFit/>
           </a:bodyPr>
+          <a:lstStyle/>
           <a:p>
             <a:pPr algn="ctr"/>
             <a:r>
@@ -4541,13 +4447,6 @@
               </a:rPr>
               <a:t>Hierarchical 1D Functions</a:t>
             </a:r>
-            <a:endParaRPr lang="en-US" altLang="en-US" sz="1200">
-              <a:solidFill>
-                <a:schemeClr val="bg1"/>
-              </a:solidFill>
-              <a:latin typeface="FreeSerif" panose="02020603050405020304" charset="0"/>
-              <a:cs typeface="FreeSerif" panose="02020603050405020304" charset="0"/>
-            </a:endParaRPr>
           </a:p>
         </p:txBody>
       </p:sp>
@@ -4578,6 +4477,7 @@
           <a:bodyPr wrap="none" rtlCol="0">
             <a:spAutoFit/>
           </a:bodyPr>
+          <a:lstStyle/>
           <a:p>
             <a:pPr algn="ctr"/>
             <a:r>
@@ -4590,13 +4490,6 @@
               </a:rPr>
               <a:t>Arbitrary d-dimensional</a:t>
             </a:r>
-            <a:endParaRPr lang="en-US" altLang="en-US" sz="1200">
-              <a:solidFill>
-                <a:schemeClr val="bg1"/>
-              </a:solidFill>
-              <a:latin typeface="FreeSerif" panose="02020603050405020304" charset="0"/>
-              <a:cs typeface="FreeSerif" panose="02020603050405020304" charset="0"/>
-            </a:endParaRPr>
           </a:p>
           <a:p>
             <a:pPr algn="ctr"/>
@@ -4610,13 +4503,6 @@
               </a:rPr>
               <a:t>Functions</a:t>
             </a:r>
-            <a:endParaRPr lang="en-US" altLang="en-US" sz="1200">
-              <a:solidFill>
-                <a:schemeClr val="bg1"/>
-              </a:solidFill>
-              <a:latin typeface="FreeSerif" panose="02020603050405020304" charset="0"/>
-              <a:cs typeface="FreeSerif" panose="02020603050405020304" charset="0"/>
-            </a:endParaRPr>
           </a:p>
         </p:txBody>
       </p:sp>
@@ -4826,7 +4712,7 @@
           <p:nvPr/>
         </p:nvPicPr>
         <p:blipFill>
-          <a:blip r:embed="rId3"/>
+          <a:blip r:embed="rId4"/>
           <a:stretch>
             <a:fillRect/>
           </a:stretch>
@@ -4863,6 +4749,7 @@
           <a:bodyPr wrap="square" rtlCol="0">
             <a:spAutoFit/>
           </a:bodyPr>
+          <a:lstStyle/>
           <a:p>
             <a:pPr algn="l"/>
             <a:r>
@@ -4875,13 +4762,6 @@
               </a:rPr>
               <a:t>Parameter Efficiency</a:t>
             </a:r>
-            <a:endParaRPr lang="en-US" altLang="en-US" sz="1400">
-              <a:solidFill>
-                <a:schemeClr val="bg1"/>
-              </a:solidFill>
-              <a:latin typeface="FreeSerif" panose="02020603050405020304" charset="0"/>
-              <a:cs typeface="FreeSerif" panose="02020603050405020304" charset="0"/>
-            </a:endParaRPr>
           </a:p>
         </p:txBody>
       </p:sp>
@@ -4894,7 +4774,7 @@
           <p:nvPr/>
         </p:nvPicPr>
         <p:blipFill>
-          <a:blip r:embed="rId4"/>
+          <a:blip r:embed="rId5"/>
           <a:stretch>
             <a:fillRect/>
           </a:stretch>
@@ -4931,6 +4811,7 @@
           <a:bodyPr wrap="square" rtlCol="0">
             <a:spAutoFit/>
           </a:bodyPr>
+          <a:lstStyle/>
           <a:p>
             <a:pPr algn="l"/>
             <a:r>
@@ -4943,13 +4824,6 @@
               </a:rPr>
               <a:t>Interpretability &amp; Discovery</a:t>
             </a:r>
-            <a:endParaRPr lang="en-US" altLang="en-US" sz="1400">
-              <a:solidFill>
-                <a:schemeClr val="bg1"/>
-              </a:solidFill>
-              <a:latin typeface="FreeSerif" panose="02020603050405020304" charset="0"/>
-              <a:cs typeface="FreeSerif" panose="02020603050405020304" charset="0"/>
-            </a:endParaRPr>
           </a:p>
         </p:txBody>
       </p:sp>
@@ -4971,7 +4845,14 @@
         <p:cNvGrpSpPr/>
         <p:nvPr/>
       </p:nvGrpSpPr>
-      <p:grpSpPr/>
+      <p:grpSpPr>
+        <a:xfrm>
+          <a:off x="0" y="0"/>
+          <a:ext cx="0" cy="0"/>
+          <a:chOff x="0" y="0"/>
+          <a:chExt cx="0" cy="0"/>
+        </a:xfrm>
+      </p:grpSpPr>
       <p:sp>
         <p:nvSpPr>
           <p:cNvPr id="7" name="Text Box 6"/>
@@ -4992,6 +4873,7 @@
           <a:bodyPr wrap="square" lIns="91440" tIns="45720" rIns="91440" bIns="45720" rtlCol="0" anchor="t">
             <a:spAutoFit/>
           </a:bodyPr>
+          <a:lstStyle/>
           <a:p>
             <a:pPr algn="ctr"/>
             <a:r>
@@ -5000,9 +4882,6 @@
               </a:rPr>
               <a:t>The MLP Assumption</a:t>
             </a:r>
-            <a:endParaRPr lang="en-US" altLang="en-US" b="1" i="1" dirty="0">
-              <a:latin typeface="FreeSerif" panose="02020603050405020304"/>
-            </a:endParaRPr>
           </a:p>
         </p:txBody>
       </p:sp>
@@ -5015,7 +4894,7 @@
           <p:nvPr/>
         </p:nvPicPr>
         <p:blipFill>
-          <a:blip r:embed="rId1"/>
+          <a:blip r:embed="rId2"/>
           <a:stretch>
             <a:fillRect/>
           </a:stretch>
@@ -5052,6 +4931,7 @@
           <a:bodyPr wrap="square" rtlCol="0">
             <a:spAutoFit/>
           </a:bodyPr>
+          <a:lstStyle/>
           <a:p>
             <a:pPr algn="ctr"/>
             <a:r>
@@ -5064,13 +4944,6 @@
               </a:rPr>
               <a:t>Catastrophic Forgetting</a:t>
             </a:r>
-            <a:endParaRPr lang="en-US" altLang="en-US" sz="1400">
-              <a:solidFill>
-                <a:schemeClr val="bg1"/>
-              </a:solidFill>
-              <a:latin typeface="FreeSerif" panose="02020603050405020304" charset="0"/>
-              <a:cs typeface="FreeSerif" panose="02020603050405020304" charset="0"/>
-            </a:endParaRPr>
           </a:p>
         </p:txBody>
       </p:sp>
@@ -5091,7 +4964,14 @@
         <p:cNvGrpSpPr/>
         <p:nvPr/>
       </p:nvGrpSpPr>
-      <p:grpSpPr/>
+      <p:grpSpPr>
+        <a:xfrm>
+          <a:off x="0" y="0"/>
+          <a:ext cx="0" cy="0"/>
+          <a:chOff x="0" y="0"/>
+          <a:chExt cx="0" cy="0"/>
+        </a:xfrm>
+      </p:grpSpPr>
       <p:sp>
         <p:nvSpPr>
           <p:cNvPr id="7" name="Text Box 6"/>
@@ -5112,6 +4992,7 @@
           <a:bodyPr wrap="square" lIns="91440" tIns="45720" rIns="91440" bIns="45720" rtlCol="0" anchor="t">
             <a:spAutoFit/>
           </a:bodyPr>
+          <a:lstStyle/>
           <a:p>
             <a:pPr algn="ctr"/>
             <a:r>
@@ -5120,9 +5001,6 @@
               </a:rPr>
               <a:t>Inductive Bias &amp; Self-Coordinating Networks</a:t>
             </a:r>
-            <a:endParaRPr lang="en-US" altLang="en-US" b="1" i="1" dirty="0">
-              <a:latin typeface="FreeSerif" panose="02020603050405020304"/>
-            </a:endParaRPr>
           </a:p>
         </p:txBody>
       </p:sp>
@@ -5148,6 +5026,7 @@
           <a:bodyPr wrap="square" rtlCol="0">
             <a:spAutoFit/>
           </a:bodyPr>
+          <a:lstStyle/>
           <a:p>
             <a:pPr algn="ctr"/>
             <a:r>
@@ -5160,13 +5039,6 @@
               </a:rPr>
               <a:t>Dense and Feed-forward Style</a:t>
             </a:r>
-            <a:endParaRPr lang="en-US" altLang="en-US" sz="1400">
-              <a:solidFill>
-                <a:schemeClr val="bg1"/>
-              </a:solidFill>
-              <a:latin typeface="FreeSerif" panose="02020603050405020304" charset="0"/>
-              <a:cs typeface="FreeSerif" panose="02020603050405020304" charset="0"/>
-            </a:endParaRPr>
           </a:p>
         </p:txBody>
       </p:sp>
@@ -5210,6 +5082,7 @@
         </p:style>
         <p:txBody>
           <a:bodyPr rtlCol="0" anchor="ctr"/>
+          <a:lstStyle/>
           <a:p>
             <a:pPr algn="ctr"/>
             <a:endParaRPr lang="en-US"/>
@@ -5256,6 +5129,7 @@
         </p:style>
         <p:txBody>
           <a:bodyPr rtlCol="0" anchor="ctr"/>
+          <a:lstStyle/>
           <a:p>
             <a:pPr algn="ctr"/>
             <a:endParaRPr lang="en-US"/>
@@ -5302,6 +5176,7 @@
         </p:style>
         <p:txBody>
           <a:bodyPr rtlCol="0" anchor="ctr"/>
+          <a:lstStyle/>
           <a:p>
             <a:pPr algn="ctr"/>
             <a:endParaRPr lang="en-US"/>
@@ -5348,6 +5223,7 @@
         </p:style>
         <p:txBody>
           <a:bodyPr rtlCol="0" anchor="ctr"/>
+          <a:lstStyle/>
           <a:p>
             <a:pPr algn="ctr"/>
             <a:endParaRPr lang="en-US"/>
@@ -5394,6 +5270,7 @@
         </p:style>
         <p:txBody>
           <a:bodyPr rtlCol="0" anchor="ctr"/>
+          <a:lstStyle/>
           <a:p>
             <a:pPr algn="ctr"/>
             <a:endParaRPr lang="en-US"/>
@@ -5440,6 +5317,7 @@
         </p:style>
         <p:txBody>
           <a:bodyPr rtlCol="0" anchor="ctr"/>
+          <a:lstStyle/>
           <a:p>
             <a:pPr algn="ctr"/>
             <a:endParaRPr lang="en-US"/>
@@ -5486,6 +5364,7 @@
         </p:style>
         <p:txBody>
           <a:bodyPr rtlCol="0" anchor="ctr"/>
+          <a:lstStyle/>
           <a:p>
             <a:pPr algn="ctr"/>
             <a:endParaRPr lang="en-US"/>
@@ -5532,6 +5411,7 @@
         </p:style>
         <p:txBody>
           <a:bodyPr rtlCol="0" anchor="ctr"/>
+          <a:lstStyle/>
           <a:p>
             <a:pPr algn="ctr"/>
             <a:endParaRPr lang="en-US"/>
@@ -5578,6 +5458,7 @@
         </p:style>
         <p:txBody>
           <a:bodyPr rtlCol="0" anchor="ctr"/>
+          <a:lstStyle/>
           <a:p>
             <a:pPr algn="ctr"/>
             <a:endParaRPr lang="en-US"/>
@@ -5624,6 +5505,7 @@
         </p:style>
         <p:txBody>
           <a:bodyPr rtlCol="0" anchor="ctr"/>
+          <a:lstStyle/>
           <a:p>
             <a:pPr algn="ctr"/>
             <a:endParaRPr lang="en-US"/>
@@ -5670,6 +5552,7 @@
         </p:style>
         <p:txBody>
           <a:bodyPr rtlCol="0" anchor="ctr"/>
+          <a:lstStyle/>
           <a:p>
             <a:pPr algn="ctr"/>
             <a:endParaRPr lang="en-US"/>
@@ -5716,6 +5599,7 @@
         </p:style>
         <p:txBody>
           <a:bodyPr rtlCol="0" anchor="ctr"/>
+          <a:lstStyle/>
           <a:p>
             <a:pPr algn="ctr"/>
             <a:endParaRPr lang="en-US"/>
@@ -5762,6 +5646,7 @@
         </p:style>
         <p:txBody>
           <a:bodyPr rtlCol="0" anchor="ctr"/>
+          <a:lstStyle/>
           <a:p>
             <a:pPr algn="ctr"/>
             <a:endParaRPr lang="en-US"/>
@@ -5808,6 +5693,7 @@
         </p:style>
         <p:txBody>
           <a:bodyPr rtlCol="0" anchor="ctr"/>
+          <a:lstStyle/>
           <a:p>
             <a:pPr algn="ctr"/>
             <a:endParaRPr lang="en-US"/>
@@ -5854,6 +5740,7 @@
         </p:style>
         <p:txBody>
           <a:bodyPr rtlCol="0" anchor="ctr"/>
+          <a:lstStyle/>
           <a:p>
             <a:pPr algn="ctr"/>
             <a:endParaRPr lang="en-US"/>
@@ -6087,6 +5974,7 @@
         </p:style>
         <p:txBody>
           <a:bodyPr rtlCol="0" anchor="ctr"/>
+          <a:lstStyle/>
           <a:p>
             <a:pPr algn="ctr"/>
             <a:endParaRPr lang="en-US"/>
@@ -6135,6 +6023,7 @@
         </p:style>
         <p:txBody>
           <a:bodyPr rtlCol="0" anchor="ctr"/>
+          <a:lstStyle/>
           <a:p>
             <a:pPr algn="ctr"/>
             <a:endParaRPr lang="en-US"/>
@@ -6190,6 +6079,7 @@
         </p:style>
         <p:txBody>
           <a:bodyPr rtlCol="0" anchor="ctr"/>
+          <a:lstStyle/>
           <a:p>
             <a:pPr algn="ctr"/>
             <a:endParaRPr lang="en-US"/>
@@ -6238,6 +6128,7 @@
         </p:style>
         <p:txBody>
           <a:bodyPr rtlCol="0" anchor="ctr"/>
+          <a:lstStyle/>
           <a:p>
             <a:pPr algn="ctr"/>
             <a:endParaRPr lang="en-US"/>
@@ -6286,6 +6177,7 @@
         </p:style>
         <p:txBody>
           <a:bodyPr rtlCol="0" anchor="ctr"/>
+          <a:lstStyle/>
           <a:p>
             <a:pPr algn="ctr"/>
             <a:endParaRPr lang="en-US"/>
@@ -6334,6 +6226,7 @@
         </p:style>
         <p:txBody>
           <a:bodyPr rtlCol="0" anchor="ctr"/>
+          <a:lstStyle/>
           <a:p>
             <a:pPr algn="ctr"/>
             <a:endParaRPr lang="en-US"/>
@@ -6389,6 +6282,7 @@
         </p:style>
         <p:txBody>
           <a:bodyPr rtlCol="0" anchor="ctr"/>
+          <a:lstStyle/>
           <a:p>
             <a:pPr algn="ctr"/>
             <a:endParaRPr lang="en-US"/>
@@ -6444,6 +6338,7 @@
         </p:style>
         <p:txBody>
           <a:bodyPr rtlCol="0" anchor="ctr"/>
+          <a:lstStyle/>
           <a:p>
             <a:pPr algn="ctr"/>
             <a:endParaRPr lang="en-US"/>
@@ -6499,6 +6394,7 @@
         </p:style>
         <p:txBody>
           <a:bodyPr rtlCol="0" anchor="ctr"/>
+          <a:lstStyle/>
           <a:p>
             <a:pPr algn="ctr"/>
             <a:endParaRPr lang="en-US"/>
@@ -6527,6 +6423,7 @@
           <a:bodyPr wrap="square" rtlCol="0">
             <a:spAutoFit/>
           </a:bodyPr>
+          <a:lstStyle/>
           <a:p>
             <a:pPr algn="ctr"/>
             <a:r>
@@ -6539,13 +6436,6 @@
               </a:rPr>
               <a:t>Self-Organizing Networks</a:t>
             </a:r>
-            <a:endParaRPr lang="en-US" altLang="en-US" sz="1400">
-              <a:solidFill>
-                <a:schemeClr val="bg1"/>
-              </a:solidFill>
-              <a:latin typeface="FreeSerif" panose="02020603050405020304" charset="0"/>
-              <a:cs typeface="FreeSerif" panose="02020603050405020304" charset="0"/>
-            </a:endParaRPr>
           </a:p>
         </p:txBody>
       </p:sp>
@@ -6883,7 +6773,7 @@
           <p:nvPr/>
         </p:nvPicPr>
         <p:blipFill>
-          <a:blip r:embed="rId1"/>
+          <a:blip r:embed="rId2"/>
           <a:stretch>
             <a:fillRect/>
           </a:stretch>
@@ -6907,14 +6797,14 @@
           <p:nvPr/>
         </p:nvPicPr>
         <p:blipFill>
-          <a:blip r:embed="rId2"/>
+          <a:blip r:embed="rId3"/>
           <a:stretch>
             <a:fillRect/>
           </a:stretch>
         </p:blipFill>
         <p:spPr>
           <a:xfrm>
-            <a:off x="3344545" y="4571365"/>
+            <a:off x="3361963" y="4571365"/>
             <a:ext cx="6926580" cy="2289175"/>
           </a:xfrm>
           <a:prstGeom prst="rect">
@@ -6944,6 +6834,7 @@
           <a:bodyPr wrap="square" rtlCol="0">
             <a:spAutoFit/>
           </a:bodyPr>
+          <a:lstStyle/>
           <a:p>
             <a:pPr algn="l"/>
             <a:r>
@@ -6956,13 +6847,6 @@
               </a:rPr>
               <a:t>Biological &amp; Physics Inspired Optimization</a:t>
             </a:r>
-            <a:endParaRPr lang="en-US" altLang="en-US" sz="1400">
-              <a:solidFill>
-                <a:schemeClr val="bg1"/>
-              </a:solidFill>
-              <a:latin typeface="FreeSerif" panose="02020603050405020304" charset="0"/>
-              <a:cs typeface="FreeSerif" panose="02020603050405020304" charset="0"/>
-            </a:endParaRPr>
           </a:p>
         </p:txBody>
       </p:sp>
@@ -6988,6 +6872,7 @@
           <a:bodyPr wrap="square" rtlCol="0">
             <a:spAutoFit/>
           </a:bodyPr>
+          <a:lstStyle/>
           <a:p>
             <a:pPr algn="l"/>
             <a:r>
@@ -7000,13 +6885,6 @@
               </a:rPr>
               <a:t>pRNNs</a:t>
             </a:r>
-            <a:endParaRPr lang="en-US" altLang="en-US" sz="1400">
-              <a:solidFill>
-                <a:schemeClr val="bg1"/>
-              </a:solidFill>
-              <a:latin typeface="FreeSerif" panose="02020603050405020304" charset="0"/>
-              <a:cs typeface="FreeSerif" panose="02020603050405020304" charset="0"/>
-            </a:endParaRPr>
           </a:p>
         </p:txBody>
       </p:sp>
@@ -7019,7 +6897,7 @@
           <p:nvPr/>
         </p:nvPicPr>
         <p:blipFill>
-          <a:blip r:embed="rId3"/>
+          <a:blip r:embed="rId4"/>
           <a:stretch>
             <a:fillRect/>
           </a:stretch>
@@ -7043,7 +6921,7 @@
           <p:nvPr/>
         </p:nvPicPr>
         <p:blipFill>
-          <a:blip r:embed="rId4"/>
+          <a:blip r:embed="rId5"/>
           <a:stretch>
             <a:fillRect/>
           </a:stretch>
@@ -7078,6 +6956,7 @@
           <a:bodyPr wrap="none" rtlCol="0">
             <a:spAutoFit/>
           </a:bodyPr>
+          <a:lstStyle/>
           <a:p>
             <a:pPr algn="ctr"/>
             <a:r>
@@ -7087,10 +6966,6 @@
               </a:rPr>
               <a:t>Static Node</a:t>
             </a:r>
-            <a:endParaRPr lang="en-US" altLang="en-US" sz="1200" b="1" i="1">
-              <a:latin typeface="FreeSerif" panose="02020603050405020304" charset="0"/>
-              <a:cs typeface="FreeSerif" panose="02020603050405020304" charset="0"/>
-            </a:endParaRPr>
           </a:p>
         </p:txBody>
       </p:sp>
@@ -7114,6 +6989,7 @@
           <a:bodyPr wrap="none" rtlCol="0">
             <a:spAutoFit/>
           </a:bodyPr>
+          <a:lstStyle/>
           <a:p>
             <a:pPr algn="ctr"/>
             <a:r>
@@ -7123,10 +6999,6 @@
               </a:rPr>
               <a:t>Adaptive Node</a:t>
             </a:r>
-            <a:endParaRPr lang="en-US" altLang="en-US" sz="1200" b="1" i="1">
-              <a:latin typeface="FreeSerif" panose="02020603050405020304" charset="0"/>
-              <a:cs typeface="FreeSerif" panose="02020603050405020304" charset="0"/>
-            </a:endParaRPr>
           </a:p>
         </p:txBody>
       </p:sp>
@@ -7147,7 +7019,14 @@
         <p:cNvGrpSpPr/>
         <p:nvPr/>
       </p:nvGrpSpPr>
-      <p:grpSpPr/>
+      <p:grpSpPr>
+        <a:xfrm>
+          <a:off x="0" y="0"/>
+          <a:ext cx="0" cy="0"/>
+          <a:chOff x="0" y="0"/>
+          <a:chExt cx="0" cy="0"/>
+        </a:xfrm>
+      </p:grpSpPr>
       <p:sp>
         <p:nvSpPr>
           <p:cNvPr id="7" name="Text Box 6"/>
@@ -7168,6 +7047,7 @@
           <a:bodyPr wrap="square" lIns="91440" tIns="45720" rIns="91440" bIns="45720" rtlCol="0" anchor="t">
             <a:spAutoFit/>
           </a:bodyPr>
+          <a:lstStyle/>
           <a:p>
             <a:pPr algn="ctr"/>
             <a:r>
@@ -7176,9 +7056,6 @@
               </a:rPr>
               <a:t>Inductive Bias &amp; Self-Coordinating Networks</a:t>
             </a:r>
-            <a:endParaRPr lang="en-US" altLang="en-US" b="1" i="1" dirty="0">
-              <a:latin typeface="FreeSerif" panose="02020603050405020304"/>
-            </a:endParaRPr>
           </a:p>
         </p:txBody>
       </p:sp>
@@ -7191,7 +7068,7 @@
           <p:nvPr/>
         </p:nvPicPr>
         <p:blipFill>
-          <a:blip r:embed="rId1"/>
+          <a:blip r:embed="rId2"/>
           <a:stretch>
             <a:fillRect/>
           </a:stretch>
@@ -7215,7 +7092,7 @@
           <p:nvPr/>
         </p:nvPicPr>
         <p:blipFill>
-          <a:blip r:embed="rId2"/>
+          <a:blip r:embed="rId3"/>
           <a:stretch>
             <a:fillRect/>
           </a:stretch>
@@ -7252,6 +7129,7 @@
           <a:bodyPr wrap="square" rtlCol="0">
             <a:spAutoFit/>
           </a:bodyPr>
+          <a:lstStyle/>
           <a:p>
             <a:pPr algn="ctr"/>
             <a:r>
@@ -7264,13 +7142,6 @@
               </a:rPr>
               <a:t>GaTaP</a:t>
             </a:r>
-            <a:endParaRPr lang="en-US" altLang="en-US" sz="1400">
-              <a:solidFill>
-                <a:schemeClr val="bg1"/>
-              </a:solidFill>
-              <a:latin typeface="FreeSerif" panose="02020603050405020304" charset="0"/>
-              <a:cs typeface="FreeSerif" panose="02020603050405020304" charset="0"/>
-            </a:endParaRPr>
           </a:p>
         </p:txBody>
       </p:sp>
@@ -7319,7 +7190,7 @@
           <p:nvPr/>
         </p:nvPicPr>
         <p:blipFill>
-          <a:blip r:embed="rId3"/>
+          <a:blip r:embed="rId4"/>
           <a:stretch>
             <a:fillRect/>
           </a:stretch>
@@ -7343,15 +7214,15 @@
           <p:nvPr/>
         </p:nvPicPr>
         <p:blipFill>
-          <a:blip r:embed="rId4"/>
+          <a:blip r:embed="rId5"/>
           <a:stretch>
             <a:fillRect/>
           </a:stretch>
         </p:blipFill>
         <p:spPr>
           <a:xfrm>
-            <a:off x="6293485" y="3710940"/>
-            <a:ext cx="5140960" cy="1866900"/>
+            <a:off x="6293485" y="3733109"/>
+            <a:ext cx="5079909" cy="1844730"/>
           </a:xfrm>
           <a:prstGeom prst="rect">
             <a:avLst/>
@@ -7367,15 +7238,15 @@
           <p:nvPr/>
         </p:nvPicPr>
         <p:blipFill>
-          <a:blip r:embed="rId5"/>
+          <a:blip r:embed="rId6"/>
           <a:stretch>
             <a:fillRect/>
           </a:stretch>
         </p:blipFill>
         <p:spPr>
           <a:xfrm>
-            <a:off x="6918325" y="5480685"/>
-            <a:ext cx="3891280" cy="1369060"/>
+            <a:off x="7019109" y="5516143"/>
+            <a:ext cx="3790496" cy="1333601"/>
           </a:xfrm>
           <a:prstGeom prst="rect">
             <a:avLst/>
@@ -7404,6 +7275,7 @@
           <a:bodyPr wrap="square" rtlCol="0">
             <a:spAutoFit/>
           </a:bodyPr>
+          <a:lstStyle/>
           <a:p>
             <a:pPr algn="ctr"/>
             <a:r>
@@ -7416,13 +7288,6 @@
               </a:rPr>
               <a:t>NCAP</a:t>
             </a:r>
-            <a:endParaRPr lang="en-US" altLang="en-US" sz="1400">
-              <a:solidFill>
-                <a:schemeClr val="bg1"/>
-              </a:solidFill>
-              <a:latin typeface="FreeSerif" panose="02020603050405020304" charset="0"/>
-              <a:cs typeface="FreeSerif" panose="02020603050405020304" charset="0"/>
-            </a:endParaRPr>
           </a:p>
         </p:txBody>
       </p:sp>
@@ -7443,7 +7308,14 @@
         <p:cNvGrpSpPr/>
         <p:nvPr/>
       </p:nvGrpSpPr>
-      <p:grpSpPr/>
+      <p:grpSpPr>
+        <a:xfrm>
+          <a:off x="0" y="0"/>
+          <a:ext cx="0" cy="0"/>
+          <a:chOff x="0" y="0"/>
+          <a:chExt cx="0" cy="0"/>
+        </a:xfrm>
+      </p:grpSpPr>
       <p:sp>
         <p:nvSpPr>
           <p:cNvPr id="7" name="Text Box 6"/>
@@ -7464,6 +7336,7 @@
           <a:bodyPr wrap="square" lIns="91440" tIns="45720" rIns="91440" bIns="45720" rtlCol="0" anchor="t">
             <a:spAutoFit/>
           </a:bodyPr>
+          <a:lstStyle/>
           <a:p>
             <a:pPr algn="ctr"/>
             <a:r>
@@ -7472,9 +7345,6 @@
               </a:rPr>
               <a:t>$1Million Research</a:t>
             </a:r>
-            <a:endParaRPr lang="en-US" altLang="en-US" b="1" i="1" dirty="0">
-              <a:latin typeface="FreeSerif" panose="02020603050405020304"/>
-            </a:endParaRPr>
           </a:p>
         </p:txBody>
       </p:sp>
@@ -7518,6 +7388,7 @@
             <a:bodyPr rot="0" spcFirstLastPara="0" vertOverflow="overflow" horzOverflow="overflow" vert="horz" wrap="square" lIns="91440" tIns="45720" rIns="91440" bIns="45720" numCol="1" spcCol="0" rtlCol="0" fromWordArt="0" anchor="t" anchorCtr="0" forceAA="0" compatLnSpc="1">
               <a:spAutoFit/>
             </a:bodyPr>
+            <a:lstStyle/>
             <a:p>
               <a:pPr marL="228600" indent="-228600" algn="l">
                 <a:lnSpc>
@@ -7531,9 +7402,6 @@
                 </a:rPr>
                 <a:t>NCAP + GaTaP:</a:t>
               </a:r>
-              <a:endParaRPr lang="en-US" altLang="en-US" sz="1200" b="1" i="1">
-                <a:latin typeface="FreeSerif" panose="02020603050405020304"/>
-              </a:endParaRPr>
             </a:p>
             <a:p>
               <a:pPr marL="685800" lvl="1" indent="-228600" algn="l">
@@ -7621,9 +7489,6 @@
                 </a:rPr>
                 <a:t>Physical Hardware Validation:</a:t>
               </a:r>
-              <a:endParaRPr lang="en-US" altLang="en-US" sz="1200" i="1">
-                <a:latin typeface="FreeSerif" panose="02020603050405020304"/>
-              </a:endParaRPr>
             </a:p>
             <a:p>
               <a:pPr marL="685800" lvl="1" indent="-228600" algn="l">
@@ -7651,9 +7516,6 @@
                 </a:rPr>
                 <a:t> and bipedal platforms</a:t>
               </a:r>
-              <a:endParaRPr lang="en-US" altLang="en-US" sz="1200" i="1">
-                <a:latin typeface="FreeSerif" panose="02020603050405020304"/>
-              </a:endParaRPr>
             </a:p>
             <a:p>
               <a:pPr marL="685800" lvl="1" indent="-228600" algn="l">
@@ -7669,9 +7531,6 @@
                 </a:rPr>
                 <a:t>Demonstrate continual adaptation across changing environments</a:t>
               </a:r>
-              <a:endParaRPr lang="en-US" altLang="en-US" sz="1200" i="1">
-                <a:latin typeface="FreeSerif" panose="02020603050405020304"/>
-              </a:endParaRPr>
             </a:p>
             <a:p>
               <a:pPr marL="685800" lvl="1" indent="-228600" algn="l">
@@ -7687,9 +7546,6 @@
                 </a:rPr>
                 <a:t>No policy retraining/simulator training</a:t>
               </a:r>
-              <a:endParaRPr lang="en-US" altLang="en-US" sz="1200" i="1">
-                <a:latin typeface="FreeSerif" panose="02020603050405020304"/>
-              </a:endParaRPr>
             </a:p>
             <a:p>
               <a:pPr marL="228600" lvl="0" indent="-228600" algn="l">
@@ -7705,9 +7561,6 @@
                 </a:rPr>
                 <a:t>Ultra-Low Compute (On Edge Devices):</a:t>
               </a:r>
-              <a:endParaRPr lang="en-US" altLang="en-US" sz="1200" i="1">
-                <a:latin typeface="FreeSerif" panose="02020603050405020304"/>
-              </a:endParaRPr>
             </a:p>
             <a:p>
               <a:pPr marL="685800" lvl="1" indent="-228600" algn="l">
@@ -7729,9 +7582,6 @@
                 </a:rPr>
                 <a:t>low-cost microcontroller/edge-chips</a:t>
               </a:r>
-              <a:endParaRPr lang="en-US" altLang="en-US" sz="1200" b="1" i="1">
-                <a:latin typeface="FreeSerif" panose="02020603050405020304"/>
-              </a:endParaRPr>
             </a:p>
           </p:txBody>
         </p:sp>
@@ -7763,6 +7613,7 @@
             <a:bodyPr rot="0" spcFirstLastPara="0" vertOverflow="overflow" horzOverflow="overflow" vert="horz" wrap="square" lIns="91440" tIns="45720" rIns="91440" bIns="45720" numCol="1" spcCol="0" rtlCol="0" fromWordArt="0" anchor="t" anchorCtr="0" forceAA="0" compatLnSpc="1">
               <a:spAutoFit/>
             </a:bodyPr>
+            <a:lstStyle/>
             <a:p>
               <a:pPr indent="0" algn="ctr">
                 <a:lnSpc>
@@ -7779,12 +7630,6 @@
                 </a:rPr>
                 <a:t>PHASE 1: PROOF OF CONCEPT (Months 0-18)</a:t>
               </a:r>
-              <a:endParaRPr lang="en-US" altLang="en-US" sz="1200" b="1">
-                <a:solidFill>
-                  <a:schemeClr val="bg1"/>
-                </a:solidFill>
-                <a:latin typeface="FreeSerif" panose="02020603050405020304"/>
-              </a:endParaRPr>
             </a:p>
           </p:txBody>
         </p:sp>
@@ -7829,6 +7674,7 @@
             <a:bodyPr rot="0" spcFirstLastPara="0" vertOverflow="overflow" horzOverflow="overflow" vert="horz" wrap="square" lIns="91440" tIns="45720" rIns="91440" bIns="45720" numCol="1" spcCol="0" rtlCol="0" fromWordArt="0" anchor="t" anchorCtr="0" forceAA="0" compatLnSpc="1">
               <a:spAutoFit/>
             </a:bodyPr>
+            <a:lstStyle/>
             <a:p>
               <a:pPr marL="228600" indent="-228600" algn="l">
                 <a:lnSpc>
@@ -7842,9 +7688,6 @@
                 </a:rPr>
                 <a:t>Improve Metrics:</a:t>
               </a:r>
-              <a:endParaRPr lang="en-US" altLang="en-US" sz="1200" b="1" i="1">
-                <a:latin typeface="FreeSerif" panose="02020603050405020304"/>
-              </a:endParaRPr>
             </a:p>
             <a:p>
               <a:pPr marL="685800" lvl="1" indent="-228600" algn="l">
@@ -7860,9 +7703,6 @@
                 </a:rPr>
                 <a:t>Improve sample efficiency by 10x</a:t>
               </a:r>
-              <a:endParaRPr lang="en-US" altLang="en-US" sz="1200" b="1" i="1">
-                <a:latin typeface="FreeSerif" panose="02020603050405020304"/>
-              </a:endParaRPr>
             </a:p>
             <a:p>
               <a:pPr marL="685800" lvl="1" indent="-228600" algn="l">
@@ -7878,9 +7718,6 @@
                 </a:rPr>
                 <a:t>Improve parameter count by 100x</a:t>
               </a:r>
-              <a:endParaRPr lang="en-US" altLang="en-US" sz="1200" b="1" i="1">
-                <a:latin typeface="FreeSerif" panose="02020603050405020304"/>
-              </a:endParaRPr>
             </a:p>
             <a:p>
               <a:pPr marL="685800" lvl="1" indent="-228600" algn="l">
@@ -7914,9 +7751,6 @@
                 </a:rPr>
                 <a:t>Raise More Funds:</a:t>
               </a:r>
-              <a:endParaRPr lang="en-US" altLang="en-US" sz="1200" i="1">
-                <a:latin typeface="FreeSerif" panose="02020603050405020304"/>
-              </a:endParaRPr>
             </a:p>
           </p:txBody>
         </p:sp>
@@ -7948,6 +7782,7 @@
             <a:bodyPr rot="0" spcFirstLastPara="0" vertOverflow="overflow" horzOverflow="overflow" vert="horz" wrap="square" lIns="91440" tIns="45720" rIns="91440" bIns="45720" numCol="1" spcCol="0" rtlCol="0" fromWordArt="0" anchor="t" anchorCtr="0" forceAA="0" compatLnSpc="1">
               <a:spAutoFit/>
             </a:bodyPr>
+            <a:lstStyle/>
             <a:p>
               <a:pPr indent="0" algn="ctr">
                 <a:lnSpc>
@@ -7981,12 +7816,6 @@
                 </a:rPr>
                 <a:t>(Months 18-24)</a:t>
               </a:r>
-              <a:endParaRPr lang="en-US" altLang="en-US" sz="1200" b="1">
-                <a:solidFill>
-                  <a:schemeClr val="bg1"/>
-                </a:solidFill>
-                <a:latin typeface="FreeSerif" panose="02020603050405020304"/>
-              </a:endParaRPr>
             </a:p>
           </p:txBody>
         </p:sp>
@@ -8031,6 +7860,7 @@
             <a:bodyPr rot="0" spcFirstLastPara="0" vertOverflow="overflow" horzOverflow="overflow" vert="horz" wrap="square" lIns="91440" tIns="45720" rIns="91440" bIns="45720" numCol="1" spcCol="0" rtlCol="0" fromWordArt="0" anchor="t" anchorCtr="0" forceAA="0" compatLnSpc="1">
               <a:spAutoFit/>
             </a:bodyPr>
+            <a:lstStyle/>
             <a:p>
               <a:pPr marL="228600" indent="-228600" algn="l">
                 <a:lnSpc>
@@ -8044,9 +7874,6 @@
                 </a:rPr>
                 <a:t>Scale Beyond Motor-Control:</a:t>
               </a:r>
-              <a:endParaRPr lang="en-US" altLang="en-US" sz="1200" b="1" i="1">
-                <a:latin typeface="FreeSerif" panose="02020603050405020304"/>
-              </a:endParaRPr>
             </a:p>
             <a:p>
               <a:pPr marL="685800" lvl="1" indent="-228600" algn="l">
@@ -8062,9 +7889,6 @@
                 </a:rPr>
                 <a:t>Extend to self-coordinating, multi-agent swarms</a:t>
               </a:r>
-              <a:endParaRPr lang="en-US" altLang="en-US" sz="1200" i="1">
-                <a:latin typeface="FreeSerif" panose="02020603050405020304"/>
-              </a:endParaRPr>
             </a:p>
             <a:p>
               <a:pPr marL="228600" lvl="0" indent="-228600" algn="l">
@@ -8080,9 +7904,6 @@
                 </a:rPr>
                 <a:t>Redundancy and Self-healing AI:</a:t>
               </a:r>
-              <a:endParaRPr lang="en-US" altLang="en-US" sz="1200" i="1">
-                <a:latin typeface="FreeSerif" panose="02020603050405020304"/>
-              </a:endParaRPr>
             </a:p>
             <a:p>
               <a:pPr marL="685800" lvl="1" indent="-228600" algn="l">
@@ -8098,9 +7919,6 @@
                 </a:rPr>
                 <a:t>Research re-wiring and pruning of networks</a:t>
               </a:r>
-              <a:endParaRPr lang="en-US" altLang="en-US" sz="1200" i="1">
-                <a:latin typeface="FreeSerif" panose="02020603050405020304"/>
-              </a:endParaRPr>
             </a:p>
             <a:p>
               <a:pPr marL="685800" lvl="1" indent="-228600" algn="l">
@@ -8116,9 +7934,6 @@
                 </a:rPr>
                 <a:t>Research adaptation to noise and hardware failures</a:t>
               </a:r>
-              <a:endParaRPr lang="en-US" altLang="en-US" sz="1200" i="1">
-                <a:latin typeface="FreeSerif" panose="02020603050405020304"/>
-              </a:endParaRPr>
             </a:p>
           </p:txBody>
         </p:sp>
@@ -8150,6 +7965,7 @@
             <a:bodyPr rot="0" spcFirstLastPara="0" vertOverflow="overflow" horzOverflow="overflow" vert="horz" wrap="square" lIns="91440" tIns="45720" rIns="91440" bIns="45720" numCol="1" spcCol="0" rtlCol="0" fromWordArt="0" anchor="t" anchorCtr="0" forceAA="0" compatLnSpc="1">
               <a:spAutoFit/>
             </a:bodyPr>
+            <a:lstStyle/>
             <a:p>
               <a:pPr indent="0" algn="ctr">
                 <a:lnSpc>
@@ -8166,12 +7982,6 @@
                 </a:rPr>
                 <a:t>PHASE 3: LONG TERM VISION (Years 2-5)</a:t>
               </a:r>
-              <a:endParaRPr lang="en-US" altLang="en-US" sz="1200" b="1">
-                <a:solidFill>
-                  <a:schemeClr val="bg1"/>
-                </a:solidFill>
-                <a:latin typeface="FreeSerif" panose="02020603050405020304"/>
-              </a:endParaRPr>
             </a:p>
           </p:txBody>
         </p:sp>
@@ -8202,6 +8012,7 @@
           <a:bodyPr wrap="square" rtlCol="0">
             <a:spAutoFit/>
           </a:bodyPr>
+          <a:lstStyle/>
           <a:p>
             <a:pPr algn="ctr"/>
             <a:r>
@@ -8235,7 +8046,14 @@
         <p:cNvGrpSpPr/>
         <p:nvPr/>
       </p:nvGrpSpPr>
-      <p:grpSpPr/>
+      <p:grpSpPr>
+        <a:xfrm>
+          <a:off x="0" y="0"/>
+          <a:ext cx="0" cy="0"/>
+          <a:chOff x="0" y="0"/>
+          <a:chExt cx="0" cy="0"/>
+        </a:xfrm>
+      </p:grpSpPr>
       <p:sp>
         <p:nvSpPr>
           <p:cNvPr id="7" name="Text Box 6"/>
@@ -8256,6 +8074,7 @@
           <a:bodyPr wrap="square" lIns="91440" tIns="45720" rIns="91440" bIns="45720" rtlCol="0" anchor="t">
             <a:spAutoFit/>
           </a:bodyPr>
+          <a:lstStyle/>
           <a:p>
             <a:pPr algn="ctr"/>
             <a:r>
@@ -8264,9 +8083,6 @@
               </a:rPr>
               <a:t>$1Million Research</a:t>
             </a:r>
-            <a:endParaRPr lang="en-US" altLang="en-US" b="1" i="1" dirty="0">
-              <a:latin typeface="FreeSerif" panose="02020603050405020304"/>
-            </a:endParaRPr>
           </a:p>
         </p:txBody>
       </p:sp>
@@ -8310,6 +8126,7 @@
             <a:bodyPr rot="0" spcFirstLastPara="0" vertOverflow="overflow" horzOverflow="overflow" vert="horz" wrap="square" lIns="91440" tIns="45720" rIns="91440" bIns="45720" numCol="1" spcCol="0" rtlCol="0" fromWordArt="0" anchor="t" anchorCtr="0" forceAA="0" compatLnSpc="1">
               <a:spAutoFit/>
             </a:bodyPr>
+            <a:lstStyle/>
             <a:p>
               <a:pPr marL="228600" indent="-228600" algn="l">
                 <a:lnSpc>
@@ -8318,14 +8135,29 @@
                 <a:buAutoNum type="arabicPeriod"/>
               </a:pPr>
               <a:r>
-                <a:rPr lang="en-US" altLang="en-US" sz="1600" b="1" i="1">
+                <a:rPr lang="en-US" altLang="en-US" sz="1600" b="1" i="1" dirty="0" err="1">
                   <a:latin typeface="FreeSerif" panose="02020603050405020304"/>
                 </a:rPr>
-                <a:t>Bhattasali, Nikhil X., et al. "Neural circuit architectural priors for quadruped locomotion." arXiv preprint arXiv:2410.07174 (2024).</a:t>
+                <a:t>Bhattasali</a:t>
               </a:r>
-              <a:endParaRPr lang="en-US" altLang="en-US" sz="1600" b="1" i="1">
-                <a:latin typeface="FreeSerif" panose="02020603050405020304"/>
-              </a:endParaRPr>
+              <a:r>
+                <a:rPr lang="en-US" altLang="en-US" sz="1600" b="1" i="1" dirty="0">
+                  <a:latin typeface="FreeSerif" panose="02020603050405020304"/>
+                </a:rPr>
+                <a:t>, Nikhil X., et al. "Neural circuit architectural priors for quadruped locomotion." </a:t>
+              </a:r>
+              <a:r>
+                <a:rPr lang="en-US" altLang="en-US" sz="1600" b="1" i="1" dirty="0" err="1">
+                  <a:latin typeface="FreeSerif" panose="02020603050405020304"/>
+                </a:rPr>
+                <a:t>arXiv</a:t>
+              </a:r>
+              <a:r>
+                <a:rPr lang="en-US" altLang="en-US" sz="1600" b="1" i="1" dirty="0">
+                  <a:latin typeface="FreeSerif" panose="02020603050405020304"/>
+                </a:rPr>
+                <a:t> preprint arXiv:2410.07174 (2024).</a:t>
+              </a:r>
             </a:p>
             <a:p>
               <a:pPr marL="228600" indent="-228600" algn="l">
@@ -8335,14 +8167,41 @@
                 <a:buAutoNum type="arabicPeriod"/>
               </a:pPr>
               <a:r>
-                <a:rPr lang="en-US" altLang="en-US" sz="1600" b="1" i="1">
+                <a:rPr lang="en-US" altLang="en-US" sz="1600" b="1" i="1" dirty="0" err="1">
                   <a:latin typeface="FreeSerif" panose="02020603050405020304"/>
                 </a:rPr>
-                <a:t>Njupoun, Abdel Mfougouon, et al. "Gated Target Propagation for Compositional Generalization in Continual Learning." arXiv preprint arXiv:2610.04649 (2026).</a:t>
+                <a:t>Njupoun</a:t>
               </a:r>
-              <a:endParaRPr lang="en-US" altLang="en-US" sz="1600" b="1" i="1">
-                <a:latin typeface="FreeSerif" panose="02020603050405020304"/>
-              </a:endParaRPr>
+              <a:r>
+                <a:rPr lang="en-US" altLang="en-US" sz="1600" b="1" i="1" dirty="0">
+                  <a:latin typeface="FreeSerif" panose="02020603050405020304"/>
+                </a:rPr>
+                <a:t>, Abdel </a:t>
+              </a:r>
+              <a:r>
+                <a:rPr lang="en-US" altLang="en-US" sz="1600" b="1" i="1" dirty="0" err="1">
+                  <a:latin typeface="FreeSerif" panose="02020603050405020304"/>
+                </a:rPr>
+                <a:t>Mfougouon</a:t>
+              </a:r>
+              <a:r>
+                <a:rPr lang="en-US" altLang="en-US" sz="1600" b="1" i="1" dirty="0">
+                  <a:latin typeface="FreeSerif" panose="02020603050405020304"/>
+                </a:rPr>
+                <a:t>, et al. "Gated Target Propagation for Compositional Generalization in Continual Learning." </a:t>
+              </a:r>
+              <a:r>
+                <a:rPr lang="en-US" altLang="en-US" sz="1600" b="1" i="1" dirty="0" err="1">
+                  <a:latin typeface="FreeSerif" panose="02020603050405020304"/>
+                </a:rPr>
+                <a:t>arXiv</a:t>
+              </a:r>
+              <a:r>
+                <a:rPr lang="en-US" altLang="en-US" sz="1600" b="1" i="1" dirty="0">
+                  <a:latin typeface="FreeSerif" panose="02020603050405020304"/>
+                </a:rPr>
+                <a:t> preprint arXiv:2610.04649 (2026).</a:t>
+              </a:r>
             </a:p>
             <a:p>
               <a:pPr marL="228600" indent="-228600" algn="l">
@@ -8352,14 +8211,71 @@
                 <a:buAutoNum type="arabicPeriod"/>
               </a:pPr>
               <a:r>
-                <a:rPr lang="en-US" altLang="en-US" sz="1600" b="1" i="1">
+                <a:rPr lang="en-US" altLang="en-US" sz="1600" b="1" i="1" dirty="0">
                   <a:latin typeface="FreeSerif" panose="02020603050405020304"/>
                 </a:rPr>
-                <a:t>Xu, Kunpeng, Lifei Chen, and Shengrui Wang. "Kolmogorov-arnold networks for time series: Bridging predictive power and interpretability." arXiv preprint arXiv:2406.02496 (2024).</a:t>
+                <a:t>Xu, </a:t>
               </a:r>
-              <a:endParaRPr lang="en-US" altLang="en-US" sz="1600" b="1" i="1">
-                <a:latin typeface="FreeSerif" panose="02020603050405020304"/>
-              </a:endParaRPr>
+              <a:r>
+                <a:rPr lang="en-US" altLang="en-US" sz="1600" b="1" i="1" dirty="0" err="1">
+                  <a:latin typeface="FreeSerif" panose="02020603050405020304"/>
+                </a:rPr>
+                <a:t>Kunpeng</a:t>
+              </a:r>
+              <a:r>
+                <a:rPr lang="en-US" altLang="en-US" sz="1600" b="1" i="1" dirty="0">
+                  <a:latin typeface="FreeSerif" panose="02020603050405020304"/>
+                </a:rPr>
+                <a:t>, </a:t>
+              </a:r>
+              <a:r>
+                <a:rPr lang="en-US" altLang="en-US" sz="1600" b="1" i="1" dirty="0" err="1">
+                  <a:latin typeface="FreeSerif" panose="02020603050405020304"/>
+                </a:rPr>
+                <a:t>Lifei</a:t>
+              </a:r>
+              <a:r>
+                <a:rPr lang="en-US" altLang="en-US" sz="1600" b="1" i="1" dirty="0">
+                  <a:latin typeface="FreeSerif" panose="02020603050405020304"/>
+                </a:rPr>
+                <a:t> Chen, and </a:t>
+              </a:r>
+              <a:r>
+                <a:rPr lang="en-US" altLang="en-US" sz="1600" b="1" i="1" dirty="0" err="1">
+                  <a:latin typeface="FreeSerif" panose="02020603050405020304"/>
+                </a:rPr>
+                <a:t>Shengrui</a:t>
+              </a:r>
+              <a:r>
+                <a:rPr lang="en-US" altLang="en-US" sz="1600" b="1" i="1" dirty="0">
+                  <a:latin typeface="FreeSerif" panose="02020603050405020304"/>
+                </a:rPr>
+                <a:t> Wang. "Kolmogorov-</a:t>
+              </a:r>
+              <a:r>
+                <a:rPr lang="en-US" altLang="en-US" sz="1600" b="1" i="1" dirty="0" err="1">
+                  <a:latin typeface="FreeSerif" panose="02020603050405020304"/>
+                </a:rPr>
+                <a:t>arnold</a:t>
+              </a:r>
+              <a:r>
+                <a:rPr lang="en-US" altLang="en-US" sz="1600" b="1" i="1" dirty="0">
+                  <a:latin typeface="FreeSerif" panose="02020603050405020304"/>
+                </a:rPr>
+                <a:t> networks for time series: Bridging predictive power and interpretability." </a:t>
+              </a:r>
+              <a:r>
+                <a:rPr lang="en-US" altLang="en-US" sz="1600" b="1" i="1" dirty="0" err="1">
+                  <a:latin typeface="FreeSerif" panose="02020603050405020304"/>
+                </a:rPr>
+                <a:t>arXiv</a:t>
+              </a:r>
+              <a:r>
+                <a:rPr lang="en-US" altLang="en-US" sz="1600" b="1" i="1" dirty="0">
+                  <a:latin typeface="FreeSerif" panose="02020603050405020304"/>
+                </a:rPr>
+                <a:t> preprint arXiv:2406.02496 (2024).</a:t>
+              </a:r>
             </a:p>
             <a:p>
               <a:pPr marL="228600" indent="-228600" algn="l">
@@ -8369,14 +8285,11 @@
                 <a:buAutoNum type="arabicPeriod"/>
               </a:pPr>
               <a:r>
-                <a:rPr lang="en-US" altLang="en-US" sz="1600" b="1" i="1">
+                <a:rPr lang="en-US" altLang="en-US" sz="1600" b="1" i="1" dirty="0">
                   <a:latin typeface="FreeSerif" panose="02020603050405020304"/>
                 </a:rPr>
                 <a:t>Ghosh, Marcus, and Dan FM Goodman. "Partially recurrent neural networks maximize performance and minimize wiring."</a:t>
               </a:r>
-              <a:endParaRPr lang="en-US" altLang="en-US" sz="1600" b="1" i="1">
-                <a:latin typeface="FreeSerif" panose="02020603050405020304"/>
-              </a:endParaRPr>
             </a:p>
             <a:p>
               <a:pPr marL="228600" indent="-228600" algn="l">
@@ -8386,14 +8299,65 @@
                 <a:buAutoNum type="arabicPeriod"/>
               </a:pPr>
               <a:r>
-                <a:rPr lang="en-US" altLang="en-US" sz="1600" b="1" i="1">
+                <a:rPr lang="en-US" altLang="en-US" sz="1600" b="1" i="1" dirty="0" err="1">
                   <a:latin typeface="FreeSerif" panose="02020603050405020304"/>
                 </a:rPr>
-                <a:t>Seyyedi, Azra, Mahdi Bohlouli, and SeyedEhsan Nedaaee Oskoee. "Self-organizing complex networks with AI-driven adaptive nodes for optimized connectivity and energy efficiency." Scientific Reports 15.1 (2025): 44527.</a:t>
+                <a:t>Seyyedi</a:t>
               </a:r>
-              <a:endParaRPr lang="en-US" altLang="en-US" sz="1600" b="1" i="1">
-                <a:latin typeface="FreeSerif" panose="02020603050405020304"/>
-              </a:endParaRPr>
+              <a:r>
+                <a:rPr lang="en-US" altLang="en-US" sz="1600" b="1" i="1" dirty="0">
+                  <a:latin typeface="FreeSerif" panose="02020603050405020304"/>
+                </a:rPr>
+                <a:t>, Azra, Mahdi </a:t>
+              </a:r>
+              <a:r>
+                <a:rPr lang="en-US" altLang="en-US" sz="1600" b="1" i="1" dirty="0" err="1">
+                  <a:latin typeface="FreeSerif" panose="02020603050405020304"/>
+                </a:rPr>
+                <a:t>Bohlouli</a:t>
+              </a:r>
+              <a:r>
+                <a:rPr lang="en-US" altLang="en-US" sz="1600" b="1" i="1" dirty="0">
+                  <a:latin typeface="FreeSerif" panose="02020603050405020304"/>
+                </a:rPr>
+                <a:t>, and </a:t>
+              </a:r>
+              <a:r>
+                <a:rPr lang="en-US" altLang="en-US" sz="1600" b="1" i="1" dirty="0" err="1">
+                  <a:latin typeface="FreeSerif" panose="02020603050405020304"/>
+                </a:rPr>
+                <a:t>SeyedEhsan</a:t>
+              </a:r>
+              <a:r>
+                <a:rPr lang="en-US" altLang="en-US" sz="1600" b="1" i="1" dirty="0">
+                  <a:latin typeface="FreeSerif" panose="02020603050405020304"/>
+                </a:rPr>
+                <a:t> </a:t>
+              </a:r>
+              <a:r>
+                <a:rPr lang="en-US" altLang="en-US" sz="1600" b="1" i="1" dirty="0" err="1">
+                  <a:latin typeface="FreeSerif" panose="02020603050405020304"/>
+                </a:rPr>
+                <a:t>Nedaaee</a:t>
+              </a:r>
+              <a:r>
+                <a:rPr lang="en-US" altLang="en-US" sz="1600" b="1" i="1" dirty="0">
+                  <a:latin typeface="FreeSerif" panose="02020603050405020304"/>
+                </a:rPr>
+                <a:t> </a:t>
+              </a:r>
+              <a:r>
+                <a:rPr lang="en-US" altLang="en-US" sz="1600" b="1" i="1" dirty="0" err="1">
+                  <a:latin typeface="FreeSerif" panose="02020603050405020304"/>
+                </a:rPr>
+                <a:t>Oskoee</a:t>
+              </a:r>
+              <a:r>
+                <a:rPr lang="en-US" altLang="en-US" sz="1600" b="1" i="1" dirty="0">
+                  <a:latin typeface="FreeSerif" panose="02020603050405020304"/>
+                </a:rPr>
+                <a:t>. "Self-organizing complex networks with AI-driven adaptive nodes for optimized connectivity and energy efficiency." Scientific Reports 15.1 (2025): 44527.</a:t>
+              </a:r>
             </a:p>
           </p:txBody>
         </p:sp>
@@ -8425,6 +8389,7 @@
             <a:bodyPr rot="0" spcFirstLastPara="0" vertOverflow="overflow" horzOverflow="overflow" vert="horz" wrap="square" lIns="91440" tIns="45720" rIns="91440" bIns="45720" numCol="1" spcCol="0" rtlCol="0" fromWordArt="0" anchor="t" anchorCtr="0" forceAA="0" compatLnSpc="1">
               <a:spAutoFit/>
             </a:bodyPr>
+            <a:lstStyle/>
             <a:p>
               <a:pPr indent="0" algn="ctr">
                 <a:lnSpc>
@@ -8441,12 +8406,6 @@
                 </a:rPr>
                 <a:t>REFERENCES</a:t>
               </a:r>
-              <a:endParaRPr lang="" altLang="en-US" sz="1600" b="1">
-                <a:solidFill>
-                  <a:schemeClr val="bg1"/>
-                </a:solidFill>
-                <a:latin typeface="FreeSerif" panose="02020603050405020304"/>
-              </a:endParaRPr>
             </a:p>
           </p:txBody>
         </p:sp>
@@ -8468,7 +8427,14 @@
         <p:cNvGrpSpPr/>
         <p:nvPr/>
       </p:nvGrpSpPr>
-      <p:grpSpPr/>
+      <p:grpSpPr>
+        <a:xfrm>
+          <a:off x="0" y="0"/>
+          <a:ext cx="0" cy="0"/>
+          <a:chOff x="0" y="0"/>
+          <a:chExt cx="0" cy="0"/>
+        </a:xfrm>
+      </p:grpSpPr>
       <p:sp>
         <p:nvSpPr>
           <p:cNvPr id="5" name="Text Box 4"/>
@@ -8489,6 +8455,7 @@
           <a:bodyPr wrap="square" rtlCol="0">
             <a:spAutoFit/>
           </a:bodyPr>
+          <a:lstStyle/>
           <a:p>
             <a:pPr algn="ctr"/>
             <a:r>
@@ -8498,10 +8465,6 @@
               </a:rPr>
               <a:t>Thank You !!!</a:t>
             </a:r>
-            <a:endParaRPr lang="en-US" altLang="en-US" sz="5400" i="1">
-              <a:latin typeface="FreeSerif" panose="02020603050405020304" charset="0"/>
-              <a:cs typeface="FreeSerif" panose="02020603050405020304" charset="0"/>
-            </a:endParaRPr>
           </a:p>
         </p:txBody>
       </p:sp>
@@ -8764,6 +8727,8 @@
       </a:bgFillStyleLst>
     </a:fmtScheme>
   </a:themeElements>
+  <a:objectDefaults/>
+  <a:extraClrSchemeLst/>
   <a:extLst>
     <a:ext uri="{05A4C25C-085E-4340-85A3-A5531E510DB2}">
       <thm15:themeFamily xmlns:thm15="http://schemas.microsoft.com/office/thememl/2012/main" name="Office Theme" id="{62F939B6-93AF-4DB8-9C6B-D6C7DFDC589F}" vid="{4A3C46E8-61CC-4603-A589-7422A47A8E4A}"/>
@@ -9023,6 +8988,8 @@
       </a:bgFillStyleLst>
     </a:fmtScheme>
   </a:themeElements>
+  <a:objectDefaults/>
+  <a:extraClrSchemeLst/>
   <a:extLst>
     <a:ext uri="{05A4C25C-085E-4340-85A3-A5531E510DB2}">
       <thm15:themeFamily xmlns:thm15="http://schemas.microsoft.com/office/thememl/2012/main" name="Office Theme" id="{62F939B6-93AF-4DB8-9C6B-D6C7DFDC589F}" vid="{4A3C46E8-61CC-4603-A589-7422A47A8E4A}"/>
@@ -9282,6 +9249,8 @@
       </a:bgFillStyleLst>
     </a:fmtScheme>
   </a:themeElements>
+  <a:objectDefaults/>
+  <a:extraClrSchemeLst/>
   <a:extLst>
     <a:ext uri="{05A4C25C-085E-4340-85A3-A5531E510DB2}">
       <thm15:themeFamily xmlns:thm15="http://schemas.microsoft.com/office/thememl/2012/main" name="Office Theme" id="{62F939B6-93AF-4DB8-9C6B-D6C7DFDC589F}" vid="{4A3C46E8-61CC-4603-A589-7422A47A8E4A}"/>

</xml_diff>